<commit_message>
Actualiza la presentacion para la Evaluacion 1
- Agrega la lamina "Alcance comprometido", que deja cerrado que entra y
  que queda fuera del proyecto, segun lo pedido para este hito.
- Incorpora notas del orador en las 18 laminas, con el reparto de quien
  presenta cada una y los tiempos estimados.
- Actualiza fechas y subtitulo a Evaluacion 1, septiembre 2026.
</commit_message>
<xml_diff>
--- a/Fase 1/Evidencias Grupales/Presentacion_PreVet_Fase1.pptx
+++ b/Fase 1/Evidencias Grupales/Presentacion_PreVet_Fase1.pptx
@@ -13,6 +13,7 @@
     <p:sldId id="261" r:id="rId12"/>
     <p:sldId id="262" r:id="rId13"/>
     <p:sldId id="263" r:id="rId14"/>
+    <p:sldId id="273" r:id="rId24"/>
     <p:sldId id="264" r:id="rId15"/>
     <p:sldId id="265" r:id="rId16"/>
     <p:sldId id="266" r:id="rId17"/>
@@ -121,6 +122,1724 @@
     </a:lvl9pPr>
   </p:defaultTextStyle>
 </p:presentation>
+</file>
+
+<file path=ppt/notesMasters/notesMaster1.xml><?xml version="1.0" encoding="utf-8"?>
+<p:notesMaster xmlns:a="http://schemas.openxmlformats.org/drawingml/2006/main" xmlns:p="http://schemas.openxmlformats.org/presentationml/2006/main" xmlns:r="http://schemas.openxmlformats.org/officeDocument/2006/relationships">
+  <p:cSld>
+    <p:bg>
+      <p:bgRef idx="1001">
+        <a:schemeClr val="bg1"/>
+      </p:bgRef>
+    </p:bg>
+    <p:spTree>
+      <p:nvGrpSpPr>
+        <p:cNvPr id="1" name=""/>
+        <p:cNvGrpSpPr/>
+        <p:nvPr/>
+      </p:nvGrpSpPr>
+      <p:grpSpPr>
+        <a:xfrm>
+          <a:off x="0" y="0"/>
+          <a:ext cx="0" cy="0"/>
+          <a:chOff x="0" y="0"/>
+          <a:chExt cx="0" cy="0"/>
+        </a:xfrm>
+      </p:grpSpPr>
+      <p:sp>
+        <p:nvSpPr>
+          <p:cNvPr id="2" name="Header Placeholder 1"/>
+          <p:cNvSpPr>
+            <a:spLocks noGrp="1"/>
+          </p:cNvSpPr>
+          <p:nvPr>
+            <p:ph type="hdr" sz="quarter"/>
+          </p:nvPr>
+        </p:nvSpPr>
+        <p:spPr>
+          <a:xfrm>
+            <a:off x="0" y="0"/>
+            <a:ext cx="2971800" cy="457200"/>
+          </a:xfrm>
+          <a:prstGeom prst="rect">
+            <a:avLst/>
+          </a:prstGeom>
+        </p:spPr>
+        <p:txBody>
+          <a:bodyPr vert="horz" lIns="91440" tIns="45720" rIns="91440" bIns="45720" rtlCol="0"/>
+          <a:lstStyle>
+            <a:lvl1pPr algn="l">
+              <a:defRPr sz="1200"/>
+            </a:lvl1pPr>
+          </a:lstStyle>
+          <a:p>
+            <a:endParaRPr lang="en-US"/>
+          </a:p>
+        </p:txBody>
+      </p:sp>
+      <p:sp>
+        <p:nvSpPr>
+          <p:cNvPr id="3" name="Date Placeholder 2"/>
+          <p:cNvSpPr>
+            <a:spLocks noGrp="1"/>
+          </p:cNvSpPr>
+          <p:nvPr>
+            <p:ph type="dt" idx="1"/>
+          </p:nvPr>
+        </p:nvSpPr>
+        <p:spPr>
+          <a:xfrm>
+            <a:off x="3884613" y="0"/>
+            <a:ext cx="2971800" cy="457200"/>
+          </a:xfrm>
+          <a:prstGeom prst="rect">
+            <a:avLst/>
+          </a:prstGeom>
+        </p:spPr>
+        <p:txBody>
+          <a:bodyPr vert="horz" lIns="91440" tIns="45720" rIns="91440" bIns="45720" rtlCol="0"/>
+          <a:lstStyle>
+            <a:lvl1pPr algn="r">
+              <a:defRPr sz="1200"/>
+            </a:lvl1pPr>
+          </a:lstStyle>
+          <a:p>
+            <a:fld id="{0F89C1C7-3DCD-1040-A9CF-14679D8B5DDD}" type="datetimeFigureOut">
+              <a:rPr lang="en-US" smtClean="0"/>
+              <a:t>10/17/16</a:t>
+            </a:fld>
+            <a:endParaRPr lang="en-US"/>
+          </a:p>
+        </p:txBody>
+      </p:sp>
+      <p:sp>
+        <p:nvSpPr>
+          <p:cNvPr id="4" name="Slide Image Placeholder 3"/>
+          <p:cNvSpPr>
+            <a:spLocks noGrp="1" noRot="1" noChangeAspect="1"/>
+          </p:cNvSpPr>
+          <p:nvPr>
+            <p:ph type="sldImg" idx="2"/>
+          </p:nvPr>
+        </p:nvSpPr>
+        <p:spPr>
+          <a:xfrm>
+            <a:off x="1143000" y="685800"/>
+            <a:ext cx="4572000" cy="3429000"/>
+          </a:xfrm>
+          <a:prstGeom prst="rect">
+            <a:avLst/>
+          </a:prstGeom>
+          <a:noFill/>
+          <a:ln w="12700">
+            <a:solidFill>
+              <a:prstClr val="black"/>
+            </a:solidFill>
+          </a:ln>
+        </p:spPr>
+        <p:txBody>
+          <a:bodyPr vert="horz" lIns="91440" tIns="45720" rIns="91440" bIns="45720" rtlCol="0" anchor="ctr"/>
+          <a:lstStyle/>
+          <a:p>
+            <a:endParaRPr lang="en-US"/>
+          </a:p>
+        </p:txBody>
+      </p:sp>
+      <p:sp>
+        <p:nvSpPr>
+          <p:cNvPr id="5" name="Notes Placeholder 4"/>
+          <p:cNvSpPr>
+            <a:spLocks noGrp="1"/>
+          </p:cNvSpPr>
+          <p:nvPr>
+            <p:ph type="body" sz="quarter" idx="3"/>
+          </p:nvPr>
+        </p:nvSpPr>
+        <p:spPr>
+          <a:xfrm>
+            <a:off x="685800" y="4343400"/>
+            <a:ext cx="5486400" cy="4114800"/>
+          </a:xfrm>
+          <a:prstGeom prst="rect">
+            <a:avLst/>
+          </a:prstGeom>
+        </p:spPr>
+        <p:txBody>
+          <a:bodyPr vert="horz" lIns="91440" tIns="45720" rIns="91440" bIns="45720" rtlCol="0"/>
+          <a:lstStyle/>
+          <a:p>
+            <a:pPr lvl="0"/>
+            <a:r>
+              <a:rPr lang="en-US" smtClean="0"/>
+              <a:t>Click to edit Master text styles</a:t>
+            </a:r>
+          </a:p>
+          <a:p>
+            <a:pPr lvl="1"/>
+            <a:r>
+              <a:rPr lang="en-US" smtClean="0"/>
+              <a:t>Second level</a:t>
+            </a:r>
+          </a:p>
+          <a:p>
+            <a:pPr lvl="2"/>
+            <a:r>
+              <a:rPr lang="en-US" smtClean="0"/>
+              <a:t>Third level</a:t>
+            </a:r>
+          </a:p>
+          <a:p>
+            <a:pPr lvl="3"/>
+            <a:r>
+              <a:rPr lang="en-US" smtClean="0"/>
+              <a:t>Fourth level</a:t>
+            </a:r>
+          </a:p>
+          <a:p>
+            <a:pPr lvl="4"/>
+            <a:r>
+              <a:rPr lang="en-US" smtClean="0"/>
+              <a:t>Fifth level</a:t>
+            </a:r>
+            <a:endParaRPr lang="en-US"/>
+          </a:p>
+        </p:txBody>
+      </p:sp>
+      <p:sp>
+        <p:nvSpPr>
+          <p:cNvPr id="6" name="Footer Placeholder 5"/>
+          <p:cNvSpPr>
+            <a:spLocks noGrp="1"/>
+          </p:cNvSpPr>
+          <p:nvPr>
+            <p:ph type="ftr" sz="quarter" idx="4"/>
+          </p:nvPr>
+        </p:nvSpPr>
+        <p:spPr>
+          <a:xfrm>
+            <a:off x="0" y="8685213"/>
+            <a:ext cx="2971800" cy="457200"/>
+          </a:xfrm>
+          <a:prstGeom prst="rect">
+            <a:avLst/>
+          </a:prstGeom>
+        </p:spPr>
+        <p:txBody>
+          <a:bodyPr vert="horz" lIns="91440" tIns="45720" rIns="91440" bIns="45720" rtlCol="0" anchor="b"/>
+          <a:lstStyle>
+            <a:lvl1pPr algn="l">
+              <a:defRPr sz="1200"/>
+            </a:lvl1pPr>
+          </a:lstStyle>
+          <a:p>
+            <a:endParaRPr lang="en-US"/>
+          </a:p>
+        </p:txBody>
+      </p:sp>
+      <p:sp>
+        <p:nvSpPr>
+          <p:cNvPr id="7" name="Slide Number Placeholder 6"/>
+          <p:cNvSpPr>
+            <a:spLocks noGrp="1"/>
+          </p:cNvSpPr>
+          <p:nvPr>
+            <p:ph type="sldNum" sz="quarter" idx="5"/>
+          </p:nvPr>
+        </p:nvSpPr>
+        <p:spPr>
+          <a:xfrm>
+            <a:off x="3884613" y="8685213"/>
+            <a:ext cx="2971800" cy="457200"/>
+          </a:xfrm>
+          <a:prstGeom prst="rect">
+            <a:avLst/>
+          </a:prstGeom>
+        </p:spPr>
+        <p:txBody>
+          <a:bodyPr vert="horz" lIns="91440" tIns="45720" rIns="91440" bIns="45720" rtlCol="0" anchor="b"/>
+          <a:lstStyle>
+            <a:lvl1pPr algn="r">
+              <a:defRPr sz="1200"/>
+            </a:lvl1pPr>
+          </a:lstStyle>
+          <a:p>
+            <a:fld id="{BB5E49A5-4136-284D-997B-48E1D791AD67}" type="slidenum">
+              <a:rPr lang="en-US" smtClean="0"/>
+              <a:t>‹#›</a:t>
+            </a:fld>
+            <a:endParaRPr lang="en-US"/>
+          </a:p>
+        </p:txBody>
+      </p:sp>
+    </p:spTree>
+    <p:extLst>
+      <p:ext uri="{BB962C8B-B14F-4D97-AF65-F5344CB8AC3E}">
+        <p14:creationId xmlns:p14="http://schemas.microsoft.com/office/powerpoint/2010/main" val="2623252185"/>
+      </p:ext>
+    </p:extLst>
+  </p:cSld>
+  <p:clrMap bg1="lt1" tx1="dk1" bg2="lt2" tx2="dk2" accent1="accent1" accent2="accent2" accent3="accent3" accent4="accent4" accent5="accent5" accent6="accent6" hlink="hlink" folHlink="folHlink"/>
+  <p:notesStyle>
+    <a:lvl1pPr marL="0" algn="l" defTabSz="457200" rtl="0" eaLnBrk="1" latinLnBrk="0" hangingPunct="1">
+      <a:defRPr sz="1200" kern="1200">
+        <a:solidFill>
+          <a:schemeClr val="tx1"/>
+        </a:solidFill>
+        <a:latin typeface="+mn-lt"/>
+        <a:ea typeface="+mn-ea"/>
+        <a:cs typeface="+mn-cs"/>
+      </a:defRPr>
+    </a:lvl1pPr>
+    <a:lvl2pPr marL="457200" algn="l" defTabSz="457200" rtl="0" eaLnBrk="1" latinLnBrk="0" hangingPunct="1">
+      <a:defRPr sz="1200" kern="1200">
+        <a:solidFill>
+          <a:schemeClr val="tx1"/>
+        </a:solidFill>
+        <a:latin typeface="+mn-lt"/>
+        <a:ea typeface="+mn-ea"/>
+        <a:cs typeface="+mn-cs"/>
+      </a:defRPr>
+    </a:lvl2pPr>
+    <a:lvl3pPr marL="914400" algn="l" defTabSz="457200" rtl="0" eaLnBrk="1" latinLnBrk="0" hangingPunct="1">
+      <a:defRPr sz="1200" kern="1200">
+        <a:solidFill>
+          <a:schemeClr val="tx1"/>
+        </a:solidFill>
+        <a:latin typeface="+mn-lt"/>
+        <a:ea typeface="+mn-ea"/>
+        <a:cs typeface="+mn-cs"/>
+      </a:defRPr>
+    </a:lvl3pPr>
+    <a:lvl4pPr marL="1371600" algn="l" defTabSz="457200" rtl="0" eaLnBrk="1" latinLnBrk="0" hangingPunct="1">
+      <a:defRPr sz="1200" kern="1200">
+        <a:solidFill>
+          <a:schemeClr val="tx1"/>
+        </a:solidFill>
+        <a:latin typeface="+mn-lt"/>
+        <a:ea typeface="+mn-ea"/>
+        <a:cs typeface="+mn-cs"/>
+      </a:defRPr>
+    </a:lvl4pPr>
+    <a:lvl5pPr marL="1828800" algn="l" defTabSz="457200" rtl="0" eaLnBrk="1" latinLnBrk="0" hangingPunct="1">
+      <a:defRPr sz="1200" kern="1200">
+        <a:solidFill>
+          <a:schemeClr val="tx1"/>
+        </a:solidFill>
+        <a:latin typeface="+mn-lt"/>
+        <a:ea typeface="+mn-ea"/>
+        <a:cs typeface="+mn-cs"/>
+      </a:defRPr>
+    </a:lvl5pPr>
+    <a:lvl6pPr marL="2286000" algn="l" defTabSz="457200" rtl="0" eaLnBrk="1" latinLnBrk="0" hangingPunct="1">
+      <a:defRPr sz="1200" kern="1200">
+        <a:solidFill>
+          <a:schemeClr val="tx1"/>
+        </a:solidFill>
+        <a:latin typeface="+mn-lt"/>
+        <a:ea typeface="+mn-ea"/>
+        <a:cs typeface="+mn-cs"/>
+      </a:defRPr>
+    </a:lvl6pPr>
+    <a:lvl7pPr marL="2743200" algn="l" defTabSz="457200" rtl="0" eaLnBrk="1" latinLnBrk="0" hangingPunct="1">
+      <a:defRPr sz="1200" kern="1200">
+        <a:solidFill>
+          <a:schemeClr val="tx1"/>
+        </a:solidFill>
+        <a:latin typeface="+mn-lt"/>
+        <a:ea typeface="+mn-ea"/>
+        <a:cs typeface="+mn-cs"/>
+      </a:defRPr>
+    </a:lvl7pPr>
+    <a:lvl8pPr marL="3200400" algn="l" defTabSz="457200" rtl="0" eaLnBrk="1" latinLnBrk="0" hangingPunct="1">
+      <a:defRPr sz="1200" kern="1200">
+        <a:solidFill>
+          <a:schemeClr val="tx1"/>
+        </a:solidFill>
+        <a:latin typeface="+mn-lt"/>
+        <a:ea typeface="+mn-ea"/>
+        <a:cs typeface="+mn-cs"/>
+      </a:defRPr>
+    </a:lvl8pPr>
+    <a:lvl9pPr marL="3657600" algn="l" defTabSz="457200" rtl="0" eaLnBrk="1" latinLnBrk="0" hangingPunct="1">
+      <a:defRPr sz="1200" kern="1200">
+        <a:solidFill>
+          <a:schemeClr val="tx1"/>
+        </a:solidFill>
+        <a:latin typeface="+mn-lt"/>
+        <a:ea typeface="+mn-ea"/>
+        <a:cs typeface="+mn-cs"/>
+      </a:defRPr>
+    </a:lvl9pPr>
+  </p:notesStyle>
+</p:notesMaster>
+</file>
+
+<file path=ppt/notesSlides/notesSlide1.xml><?xml version="1.0" encoding="utf-8"?>
+<p:notes xmlns:a="http://schemas.openxmlformats.org/drawingml/2006/main" xmlns:p="http://schemas.openxmlformats.org/presentationml/2006/main" xmlns:r="http://schemas.openxmlformats.org/officeDocument/2006/relationships">
+  <p:cSld>
+    <p:spTree>
+      <p:nvGrpSpPr>
+        <p:cNvPr id="1" name=""/>
+        <p:cNvGrpSpPr/>
+        <p:nvPr/>
+      </p:nvGrpSpPr>
+      <p:grpSpPr>
+        <a:xfrm>
+          <a:off x="0" y="0"/>
+          <a:ext cx="0" cy="0"/>
+          <a:chOff x="0" y="0"/>
+          <a:chExt cx="0" cy="0"/>
+        </a:xfrm>
+      </p:grpSpPr>
+      <p:sp>
+        <p:nvSpPr>
+          <p:cNvPr id="2" name="Slide Image Placeholder 1"/>
+          <p:cNvSpPr>
+            <a:spLocks noGrp="1"/>
+          </p:cNvSpPr>
+          <p:nvPr>
+            <p:ph type="sldImg" idx="2"/>
+          </p:nvPr>
+        </p:nvSpPr>
+        <p:spPr/>
+      </p:sp>
+      <p:sp>
+        <p:nvSpPr>
+          <p:cNvPr id="3" name="Notes Placeholder 2"/>
+          <p:cNvSpPr>
+            <a:spLocks noGrp="1"/>
+          </p:cNvSpPr>
+          <p:nvPr>
+            <p:ph type="body" idx="3" sz="quarter"/>
+          </p:nvPr>
+        </p:nvSpPr>
+        <p:spPr/>
+        <p:txBody>
+          <a:bodyPr/>
+          <a:lstStyle/>
+          <a:p>
+            <a:r>
+              <a:t>UCIELL — Apertura (30 s)</a:t>
+            </a:r>
+          </a:p>
+          <a:p/>
+          <a:p>
+            <a:r>
+              <a:t>Buenos días. Somos Katalina Mora y Uciell Madrid. Nuestro proyecto se llama PreVet y resuelve un problema que las clínicas veterinarias pequeñas tienen todos los días y no pueden ni siquiera medir.</a:t>
+            </a:r>
+          </a:p>
+        </p:txBody>
+      </p:sp>
+      <p:sp>
+        <p:nvSpPr>
+          <p:cNvPr id="4" name="Slide Number Placeholder 3"/>
+          <p:cNvSpPr>
+            <a:spLocks noGrp="1"/>
+          </p:cNvSpPr>
+          <p:nvPr>
+            <p:ph type="sldNum" idx="5" sz="quarter"/>
+          </p:nvPr>
+        </p:nvSpPr>
+        <p:spPr/>
+      </p:sp>
+    </p:spTree>
+  </p:cSld>
+  <p:clrMapOvr>
+    <a:masterClrMapping/>
+  </p:clrMapOvr>
+</p:notes>
+</file>
+
+<file path=ppt/notesSlides/notesSlide10.xml><?xml version="1.0" encoding="utf-8"?>
+<p:notes xmlns:a="http://schemas.openxmlformats.org/drawingml/2006/main" xmlns:p="http://schemas.openxmlformats.org/presentationml/2006/main" xmlns:r="http://schemas.openxmlformats.org/officeDocument/2006/relationships">
+  <p:cSld>
+    <p:spTree>
+      <p:nvGrpSpPr>
+        <p:cNvPr id="1" name=""/>
+        <p:cNvGrpSpPr/>
+        <p:nvPr/>
+      </p:nvGrpSpPr>
+      <p:grpSpPr>
+        <a:xfrm>
+          <a:off x="0" y="0"/>
+          <a:ext cx="0" cy="0"/>
+          <a:chOff x="0" y="0"/>
+          <a:chExt cx="0" cy="0"/>
+        </a:xfrm>
+      </p:grpSpPr>
+      <p:sp>
+        <p:nvSpPr>
+          <p:cNvPr id="2" name="Slide Image Placeholder 1"/>
+          <p:cNvSpPr>
+            <a:spLocks noGrp="1"/>
+          </p:cNvSpPr>
+          <p:nvPr>
+            <p:ph type="sldImg" idx="2"/>
+          </p:nvPr>
+        </p:nvSpPr>
+        <p:spPr/>
+      </p:sp>
+      <p:sp>
+        <p:nvSpPr>
+          <p:cNvPr id="3" name="Notes Placeholder 2"/>
+          <p:cNvSpPr>
+            <a:spLocks noGrp="1"/>
+          </p:cNvSpPr>
+          <p:nvPr>
+            <p:ph type="body" idx="3" sz="quarter"/>
+          </p:nvPr>
+        </p:nvSpPr>
+        <p:spPr/>
+        <p:txBody>
+          <a:bodyPr/>
+          <a:lstStyle/>
+          <a:p>
+            <a:r>
+              <a:t>UCIELL — Mock-up de la app (1 min)</a:t>
+            </a:r>
+          </a:p>
+          <a:p/>
+          <a:p>
+            <a:r>
+              <a:t>Así se vería la app del tutor: elegir tipo de atención, elegir profesional, y gestionar sus horas. Lo importante no es que sea bonita: es el canal que captura los datos que hoy no existen — quién reserva, cuándo, con cuánta anticipación, si confirma o cancela. Sin esos datos no hay predicción posible.</a:t>
+            </a:r>
+          </a:p>
+        </p:txBody>
+      </p:sp>
+      <p:sp>
+        <p:nvSpPr>
+          <p:cNvPr id="4" name="Slide Number Placeholder 3"/>
+          <p:cNvSpPr>
+            <a:spLocks noGrp="1"/>
+          </p:cNvSpPr>
+          <p:nvPr>
+            <p:ph type="sldNum" idx="5" sz="quarter"/>
+          </p:nvPr>
+        </p:nvSpPr>
+        <p:spPr/>
+      </p:sp>
+    </p:spTree>
+  </p:cSld>
+  <p:clrMapOvr>
+    <a:masterClrMapping/>
+  </p:clrMapOvr>
+</p:notes>
+</file>
+
+<file path=ppt/notesSlides/notesSlide11.xml><?xml version="1.0" encoding="utf-8"?>
+<p:notes xmlns:a="http://schemas.openxmlformats.org/drawingml/2006/main" xmlns:p="http://schemas.openxmlformats.org/presentationml/2006/main" xmlns:r="http://schemas.openxmlformats.org/officeDocument/2006/relationships">
+  <p:cSld>
+    <p:spTree>
+      <p:nvGrpSpPr>
+        <p:cNvPr id="1" name=""/>
+        <p:cNvGrpSpPr/>
+        <p:nvPr/>
+      </p:nvGrpSpPr>
+      <p:grpSpPr>
+        <a:xfrm>
+          <a:off x="0" y="0"/>
+          <a:ext cx="0" cy="0"/>
+          <a:chOff x="0" y="0"/>
+          <a:chExt cx="0" cy="0"/>
+        </a:xfrm>
+      </p:grpSpPr>
+      <p:sp>
+        <p:nvSpPr>
+          <p:cNvPr id="2" name="Slide Image Placeholder 1"/>
+          <p:cNvSpPr>
+            <a:spLocks noGrp="1"/>
+          </p:cNvSpPr>
+          <p:nvPr>
+            <p:ph type="sldImg" idx="2"/>
+          </p:nvPr>
+        </p:nvSpPr>
+        <p:spPr/>
+      </p:sp>
+      <p:sp>
+        <p:nvSpPr>
+          <p:cNvPr id="3" name="Notes Placeholder 2"/>
+          <p:cNvSpPr>
+            <a:spLocks noGrp="1"/>
+          </p:cNvSpPr>
+          <p:nvPr>
+            <p:ph type="body" idx="3" sz="quarter"/>
+          </p:nvPr>
+        </p:nvSpPr>
+        <p:spPr/>
+        <p:txBody>
+          <a:bodyPr/>
+          <a:lstStyle/>
+          <a:p>
+            <a:r>
+              <a:t>KATALINA — Mock-up del tablero (1,5 min)</a:t>
+            </a:r>
+          </a:p>
+          <a:p/>
+          <a:p>
+            <a:r>
+              <a:t>Esto es lo que ve la administradora de la clínica cada mañana. Arriba los indicadores: cuántas horas se agendaron, la tasa de inasistencia y cuánto dinero representa. Abajo a la izquierda el patrón por día. Y a la derecha lo importante: las horas en riesgo de los próximos días, con la acción recomendada para cada una. Los números son de ejemplo; los reales salen de la entrevista con la clínica.</a:t>
+            </a:r>
+          </a:p>
+        </p:txBody>
+      </p:sp>
+      <p:sp>
+        <p:nvSpPr>
+          <p:cNvPr id="4" name="Slide Number Placeholder 3"/>
+          <p:cNvSpPr>
+            <a:spLocks noGrp="1"/>
+          </p:cNvSpPr>
+          <p:nvPr>
+            <p:ph type="sldNum" idx="5" sz="quarter"/>
+          </p:nvPr>
+        </p:nvSpPr>
+        <p:spPr/>
+      </p:sp>
+    </p:spTree>
+  </p:cSld>
+  <p:clrMapOvr>
+    <a:masterClrMapping/>
+  </p:clrMapOvr>
+</p:notes>
+</file>
+
+<file path=ppt/notesSlides/notesSlide12.xml><?xml version="1.0" encoding="utf-8"?>
+<p:notes xmlns:a="http://schemas.openxmlformats.org/drawingml/2006/main" xmlns:p="http://schemas.openxmlformats.org/presentationml/2006/main" xmlns:r="http://schemas.openxmlformats.org/officeDocument/2006/relationships">
+  <p:cSld>
+    <p:spTree>
+      <p:nvGrpSpPr>
+        <p:cNvPr id="1" name=""/>
+        <p:cNvGrpSpPr/>
+        <p:nvPr/>
+      </p:nvGrpSpPr>
+      <p:grpSpPr>
+        <a:xfrm>
+          <a:off x="0" y="0"/>
+          <a:ext cx="0" cy="0"/>
+          <a:chOff x="0" y="0"/>
+          <a:chExt cx="0" cy="0"/>
+        </a:xfrm>
+      </p:grpSpPr>
+      <p:sp>
+        <p:nvSpPr>
+          <p:cNvPr id="2" name="Slide Image Placeholder 1"/>
+          <p:cNvSpPr>
+            <a:spLocks noGrp="1"/>
+          </p:cNvSpPr>
+          <p:nvPr>
+            <p:ph type="sldImg" idx="2"/>
+          </p:nvPr>
+        </p:nvSpPr>
+        <p:spPr/>
+      </p:sp>
+      <p:sp>
+        <p:nvSpPr>
+          <p:cNvPr id="3" name="Notes Placeholder 2"/>
+          <p:cNvSpPr>
+            <a:spLocks noGrp="1"/>
+          </p:cNvSpPr>
+          <p:nvPr>
+            <p:ph type="body" idx="3" sz="quarter"/>
+          </p:nvPr>
+        </p:nvSpPr>
+        <p:spPr/>
+        <p:txBody>
+          <a:bodyPr/>
+          <a:lstStyle/>
+          <a:p>
+            <a:r>
+              <a:t>KATALINA — Arquitectura (1 min)</a:t>
+            </a:r>
+          </a:p>
+          <a:p/>
+          <a:p>
+            <a:r>
+              <a:t>Las dos primeras filas marcan la diferencia: el sistema base es preexistente, la extensión es nuestra. El resto son herramientas gratuitas o de licencia estudiante, así que el proyecto no requiere inversión. El tablero va en Power BI conectado a la misma base.</a:t>
+            </a:r>
+          </a:p>
+        </p:txBody>
+      </p:sp>
+      <p:sp>
+        <p:nvSpPr>
+          <p:cNvPr id="4" name="Slide Number Placeholder 3"/>
+          <p:cNvSpPr>
+            <a:spLocks noGrp="1"/>
+          </p:cNvSpPr>
+          <p:nvPr>
+            <p:ph type="sldNum" idx="5" sz="quarter"/>
+          </p:nvPr>
+        </p:nvSpPr>
+        <p:spPr/>
+      </p:sp>
+    </p:spTree>
+  </p:cSld>
+  <p:clrMapOvr>
+    <a:masterClrMapping/>
+  </p:clrMapOvr>
+</p:notes>
+</file>
+
+<file path=ppt/notesSlides/notesSlide13.xml><?xml version="1.0" encoding="utf-8"?>
+<p:notes xmlns:a="http://schemas.openxmlformats.org/drawingml/2006/main" xmlns:p="http://schemas.openxmlformats.org/presentationml/2006/main" xmlns:r="http://schemas.openxmlformats.org/officeDocument/2006/relationships">
+  <p:cSld>
+    <p:spTree>
+      <p:nvGrpSpPr>
+        <p:cNvPr id="1" name=""/>
+        <p:cNvGrpSpPr/>
+        <p:nvPr/>
+      </p:nvGrpSpPr>
+      <p:grpSpPr>
+        <a:xfrm>
+          <a:off x="0" y="0"/>
+          <a:ext cx="0" cy="0"/>
+          <a:chOff x="0" y="0"/>
+          <a:chExt cx="0" cy="0"/>
+        </a:xfrm>
+      </p:grpSpPr>
+      <p:sp>
+        <p:nvSpPr>
+          <p:cNvPr id="2" name="Slide Image Placeholder 1"/>
+          <p:cNvSpPr>
+            <a:spLocks noGrp="1"/>
+          </p:cNvSpPr>
+          <p:nvPr>
+            <p:ph type="sldImg" idx="2"/>
+          </p:nvPr>
+        </p:nvSpPr>
+        <p:spPr/>
+      </p:sp>
+      <p:sp>
+        <p:nvSpPr>
+          <p:cNvPr id="3" name="Notes Placeholder 2"/>
+          <p:cNvSpPr>
+            <a:spLocks noGrp="1"/>
+          </p:cNvSpPr>
+          <p:nvPr>
+            <p:ph type="body" idx="3" sz="quarter"/>
+          </p:nvPr>
+        </p:nvSpPr>
+        <p:spPr/>
+        <p:txBody>
+          <a:bodyPr/>
+          <a:lstStyle/>
+          <a:p>
+            <a:r>
+              <a:t>UCIELL — Metodología (1 min)</a:t>
+            </a:r>
+          </a:p>
+          <a:p/>
+          <a:p>
+            <a:r>
+              <a:t>Usamos dos marcos que no compiten. CRISP-DM ordena el trabajo analítico, que es el estándar en proyectos de datos. Y un marco ágil ordena la gestión, en incrementos de dos semanas con un entregable verificable cada uno. Más gestión de riesgos y plan de pruebas de forma transversal. Si preguntan por qué dos: una es para el análisis, la otra para la gestión.</a:t>
+            </a:r>
+          </a:p>
+        </p:txBody>
+      </p:sp>
+      <p:sp>
+        <p:nvSpPr>
+          <p:cNvPr id="4" name="Slide Number Placeholder 3"/>
+          <p:cNvSpPr>
+            <a:spLocks noGrp="1"/>
+          </p:cNvSpPr>
+          <p:nvPr>
+            <p:ph type="sldNum" idx="5" sz="quarter"/>
+          </p:nvPr>
+        </p:nvSpPr>
+        <p:spPr/>
+      </p:sp>
+    </p:spTree>
+  </p:cSld>
+  <p:clrMapOvr>
+    <a:masterClrMapping/>
+  </p:clrMapOvr>
+</p:notes>
+</file>
+
+<file path=ppt/notesSlides/notesSlide14.xml><?xml version="1.0" encoding="utf-8"?>
+<p:notes xmlns:a="http://schemas.openxmlformats.org/drawingml/2006/main" xmlns:p="http://schemas.openxmlformats.org/presentationml/2006/main" xmlns:r="http://schemas.openxmlformats.org/officeDocument/2006/relationships">
+  <p:cSld>
+    <p:spTree>
+      <p:nvGrpSpPr>
+        <p:cNvPr id="1" name=""/>
+        <p:cNvGrpSpPr/>
+        <p:nvPr/>
+      </p:nvGrpSpPr>
+      <p:grpSpPr>
+        <a:xfrm>
+          <a:off x="0" y="0"/>
+          <a:ext cx="0" cy="0"/>
+          <a:chOff x="0" y="0"/>
+          <a:chExt cx="0" cy="0"/>
+        </a:xfrm>
+      </p:grpSpPr>
+      <p:sp>
+        <p:nvSpPr>
+          <p:cNvPr id="2" name="Slide Image Placeholder 1"/>
+          <p:cNvSpPr>
+            <a:spLocks noGrp="1"/>
+          </p:cNvSpPr>
+          <p:nvPr>
+            <p:ph type="sldImg" idx="2"/>
+          </p:nvPr>
+        </p:nvSpPr>
+        <p:spPr/>
+      </p:sp>
+      <p:sp>
+        <p:nvSpPr>
+          <p:cNvPr id="3" name="Notes Placeholder 2"/>
+          <p:cNvSpPr>
+            <a:spLocks noGrp="1"/>
+          </p:cNvSpPr>
+          <p:nvPr>
+            <p:ph type="body" idx="3" sz="quarter"/>
+          </p:nvPr>
+        </p:nvSpPr>
+        <p:spPr/>
+        <p:txBody>
+          <a:bodyPr/>
+          <a:lstStyle/>
+          <a:p>
+            <a:r>
+              <a:t>UCIELL — Competencias (45 s)</a:t>
+            </a:r>
+          </a:p>
+          <a:p/>
+          <a:p>
+            <a:r>
+              <a:t>El proyecto pone en práctica tres competencias del perfil de egreso, y en la última columna está el indicador de calidad que cubre cada una. Las seis certificaciones de módulo que tenemos respaldan justamente estas áreas.</a:t>
+            </a:r>
+          </a:p>
+        </p:txBody>
+      </p:sp>
+      <p:sp>
+        <p:nvSpPr>
+          <p:cNvPr id="4" name="Slide Number Placeholder 3"/>
+          <p:cNvSpPr>
+            <a:spLocks noGrp="1"/>
+          </p:cNvSpPr>
+          <p:nvPr>
+            <p:ph type="sldNum" idx="5" sz="quarter"/>
+          </p:nvPr>
+        </p:nvSpPr>
+        <p:spPr/>
+      </p:sp>
+    </p:spTree>
+  </p:cSld>
+  <p:clrMapOvr>
+    <a:masterClrMapping/>
+  </p:clrMapOvr>
+</p:notes>
+</file>
+
+<file path=ppt/notesSlides/notesSlide15.xml><?xml version="1.0" encoding="utf-8"?>
+<p:notes xmlns:a="http://schemas.openxmlformats.org/drawingml/2006/main" xmlns:p="http://schemas.openxmlformats.org/presentationml/2006/main" xmlns:r="http://schemas.openxmlformats.org/officeDocument/2006/relationships">
+  <p:cSld>
+    <p:spTree>
+      <p:nvGrpSpPr>
+        <p:cNvPr id="1" name=""/>
+        <p:cNvGrpSpPr/>
+        <p:nvPr/>
+      </p:nvGrpSpPr>
+      <p:grpSpPr>
+        <a:xfrm>
+          <a:off x="0" y="0"/>
+          <a:ext cx="0" cy="0"/>
+          <a:chOff x="0" y="0"/>
+          <a:chExt cx="0" cy="0"/>
+        </a:xfrm>
+      </p:grpSpPr>
+      <p:sp>
+        <p:nvSpPr>
+          <p:cNvPr id="2" name="Slide Image Placeholder 1"/>
+          <p:cNvSpPr>
+            <a:spLocks noGrp="1"/>
+          </p:cNvSpPr>
+          <p:nvPr>
+            <p:ph type="sldImg" idx="2"/>
+          </p:nvPr>
+        </p:nvSpPr>
+        <p:spPr/>
+      </p:sp>
+      <p:sp>
+        <p:nvSpPr>
+          <p:cNvPr id="3" name="Notes Placeholder 2"/>
+          <p:cNvSpPr>
+            <a:spLocks noGrp="1"/>
+          </p:cNvSpPr>
+          <p:nvPr>
+            <p:ph type="body" idx="3" sz="quarter"/>
+          </p:nvPr>
+        </p:nvSpPr>
+        <p:spPr/>
+        <p:txBody>
+          <a:bodyPr/>
+          <a:lstStyle/>
+          <a:p>
+            <a:r>
+              <a:t>AMBAS — El equipo (45 s)</a:t>
+            </a:r>
+          </a:p>
+          <a:p/>
+          <a:p>
+            <a:r>
+              <a:t>Katalina: datos, modelo de riesgo, tablero y gestión del proyecto. Uciell: análisis funcional, preparación de datos, prototipo y calidad. Cada una explica su propia parte en esta lámina.</a:t>
+            </a:r>
+          </a:p>
+        </p:txBody>
+      </p:sp>
+      <p:sp>
+        <p:nvSpPr>
+          <p:cNvPr id="4" name="Slide Number Placeholder 3"/>
+          <p:cNvSpPr>
+            <a:spLocks noGrp="1"/>
+          </p:cNvSpPr>
+          <p:nvPr>
+            <p:ph type="sldNum" idx="5" sz="quarter"/>
+          </p:nvPr>
+        </p:nvSpPr>
+        <p:spPr/>
+      </p:sp>
+    </p:spTree>
+  </p:cSld>
+  <p:clrMapOvr>
+    <a:masterClrMapping/>
+  </p:clrMapOvr>
+</p:notes>
+</file>
+
+<file path=ppt/notesSlides/notesSlide16.xml><?xml version="1.0" encoding="utf-8"?>
+<p:notes xmlns:a="http://schemas.openxmlformats.org/drawingml/2006/main" xmlns:p="http://schemas.openxmlformats.org/presentationml/2006/main" xmlns:r="http://schemas.openxmlformats.org/officeDocument/2006/relationships">
+  <p:cSld>
+    <p:spTree>
+      <p:nvGrpSpPr>
+        <p:cNvPr id="1" name=""/>
+        <p:cNvGrpSpPr/>
+        <p:nvPr/>
+      </p:nvGrpSpPr>
+      <p:grpSpPr>
+        <a:xfrm>
+          <a:off x="0" y="0"/>
+          <a:ext cx="0" cy="0"/>
+          <a:chOff x="0" y="0"/>
+          <a:chExt cx="0" cy="0"/>
+        </a:xfrm>
+      </p:grpSpPr>
+      <p:sp>
+        <p:nvSpPr>
+          <p:cNvPr id="2" name="Slide Image Placeholder 1"/>
+          <p:cNvSpPr>
+            <a:spLocks noGrp="1"/>
+          </p:cNvSpPr>
+          <p:nvPr>
+            <p:ph type="sldImg" idx="2"/>
+          </p:nvPr>
+        </p:nvSpPr>
+        <p:spPr/>
+      </p:sp>
+      <p:sp>
+        <p:nvSpPr>
+          <p:cNvPr id="3" name="Notes Placeholder 2"/>
+          <p:cNvSpPr>
+            <a:spLocks noGrp="1"/>
+          </p:cNvSpPr>
+          <p:nvPr>
+            <p:ph type="body" idx="3" sz="quarter"/>
+          </p:nvPr>
+        </p:nvSpPr>
+        <p:spPr/>
+        <p:txBody>
+          <a:bodyPr/>
+          <a:lstStyle/>
+          <a:p>
+            <a:r>
+              <a:t>KATALINA — Plan de trabajo (45 s)</a:t>
+            </a:r>
+          </a:p>
+          <a:p/>
+          <a:p>
+            <a:r>
+              <a:t>Doce actividades en las 18 semanas, repartidas en las tres fases. Fíjense en que las actividades se superponen a propósito, para que ninguna de las dos quede esperando el trabajo de la otra.</a:t>
+            </a:r>
+          </a:p>
+        </p:txBody>
+      </p:sp>
+      <p:sp>
+        <p:nvSpPr>
+          <p:cNvPr id="4" name="Slide Number Placeholder 3"/>
+          <p:cNvSpPr>
+            <a:spLocks noGrp="1"/>
+          </p:cNvSpPr>
+          <p:nvPr>
+            <p:ph type="sldNum" idx="5" sz="quarter"/>
+          </p:nvPr>
+        </p:nvSpPr>
+        <p:spPr/>
+      </p:sp>
+    </p:spTree>
+  </p:cSld>
+  <p:clrMapOvr>
+    <a:masterClrMapping/>
+  </p:clrMapOvr>
+</p:notes>
+</file>
+
+<file path=ppt/notesSlides/notesSlide17.xml><?xml version="1.0" encoding="utf-8"?>
+<p:notes xmlns:a="http://schemas.openxmlformats.org/drawingml/2006/main" xmlns:p="http://schemas.openxmlformats.org/presentationml/2006/main" xmlns:r="http://schemas.openxmlformats.org/officeDocument/2006/relationships">
+  <p:cSld>
+    <p:spTree>
+      <p:nvGrpSpPr>
+        <p:cNvPr id="1" name=""/>
+        <p:cNvGrpSpPr/>
+        <p:nvPr/>
+      </p:nvGrpSpPr>
+      <p:grpSpPr>
+        <a:xfrm>
+          <a:off x="0" y="0"/>
+          <a:ext cx="0" cy="0"/>
+          <a:chOff x="0" y="0"/>
+          <a:chExt cx="0" cy="0"/>
+        </a:xfrm>
+      </p:grpSpPr>
+      <p:sp>
+        <p:nvSpPr>
+          <p:cNvPr id="2" name="Slide Image Placeholder 1"/>
+          <p:cNvSpPr>
+            <a:spLocks noGrp="1"/>
+          </p:cNvSpPr>
+          <p:nvPr>
+            <p:ph type="sldImg" idx="2"/>
+          </p:nvPr>
+        </p:nvSpPr>
+        <p:spPr/>
+      </p:sp>
+      <p:sp>
+        <p:nvSpPr>
+          <p:cNvPr id="3" name="Notes Placeholder 2"/>
+          <p:cNvSpPr>
+            <a:spLocks noGrp="1"/>
+          </p:cNvSpPr>
+          <p:nvPr>
+            <p:ph type="body" idx="3" sz="quarter"/>
+          </p:nvPr>
+        </p:nvSpPr>
+        <p:spPr/>
+        <p:txBody>
+          <a:bodyPr/>
+          <a:lstStyle/>
+          <a:p>
+            <a:r>
+              <a:t>KATALINA — Riesgos (1 min)</a:t>
+            </a:r>
+          </a:p>
+          <a:p/>
+          <a:p>
+            <a:r>
+              <a:t>El riesgo principal era no tener datos históricos, y lo resolvimos: el sistema base ya trae un generador de datos de demostración que vamos a extender para producir historial de inasistencias con las tasas reales que nos reporte la clínica. Y la frase de abajo es importante: el proyecto se completa aunque el machine learning no alcance a desarrollarse.</a:t>
+            </a:r>
+          </a:p>
+        </p:txBody>
+      </p:sp>
+      <p:sp>
+        <p:nvSpPr>
+          <p:cNvPr id="4" name="Slide Number Placeholder 3"/>
+          <p:cNvSpPr>
+            <a:spLocks noGrp="1"/>
+          </p:cNvSpPr>
+          <p:nvPr>
+            <p:ph type="sldNum" idx="5" sz="quarter"/>
+          </p:nvPr>
+        </p:nvSpPr>
+        <p:spPr/>
+      </p:sp>
+    </p:spTree>
+  </p:cSld>
+  <p:clrMapOvr>
+    <a:masterClrMapping/>
+  </p:clrMapOvr>
+</p:notes>
+</file>
+
+<file path=ppt/notesSlides/notesSlide18.xml><?xml version="1.0" encoding="utf-8"?>
+<p:notes xmlns:a="http://schemas.openxmlformats.org/drawingml/2006/main" xmlns:p="http://schemas.openxmlformats.org/presentationml/2006/main" xmlns:r="http://schemas.openxmlformats.org/officeDocument/2006/relationships">
+  <p:cSld>
+    <p:spTree>
+      <p:nvGrpSpPr>
+        <p:cNvPr id="1" name=""/>
+        <p:cNvGrpSpPr/>
+        <p:nvPr/>
+      </p:nvGrpSpPr>
+      <p:grpSpPr>
+        <a:xfrm>
+          <a:off x="0" y="0"/>
+          <a:ext cx="0" cy="0"/>
+          <a:chOff x="0" y="0"/>
+          <a:chExt cx="0" cy="0"/>
+        </a:xfrm>
+      </p:grpSpPr>
+      <p:sp>
+        <p:nvSpPr>
+          <p:cNvPr id="2" name="Slide Image Placeholder 1"/>
+          <p:cNvSpPr>
+            <a:spLocks noGrp="1"/>
+          </p:cNvSpPr>
+          <p:nvPr>
+            <p:ph type="sldImg" idx="2"/>
+          </p:nvPr>
+        </p:nvSpPr>
+        <p:spPr/>
+      </p:sp>
+      <p:sp>
+        <p:nvSpPr>
+          <p:cNvPr id="3" name="Notes Placeholder 2"/>
+          <p:cNvSpPr>
+            <a:spLocks noGrp="1"/>
+          </p:cNvSpPr>
+          <p:nvPr>
+            <p:ph type="body" idx="3" sz="quarter"/>
+          </p:nvPr>
+        </p:nvSpPr>
+        <p:spPr/>
+        <p:txBody>
+          <a:bodyPr/>
+          <a:lstStyle/>
+          <a:p>
+            <a:r>
+              <a:t>UCIELL — Cierre (30 s)</a:t>
+            </a:r>
+          </a:p>
+          <a:p/>
+          <a:p>
+            <a:r>
+              <a:t>Para cerrar: las clínicas veterinarias chicas pierden horas y ni siquiera pueden medir cuántas. PreVet estructura esos datos y anticipa qué hora se va a perder, antes de que ocurra. Muchas gracias. Quedamos atentas a sus preguntas.</a:t>
+            </a:r>
+          </a:p>
+        </p:txBody>
+      </p:sp>
+      <p:sp>
+        <p:nvSpPr>
+          <p:cNvPr id="4" name="Slide Number Placeholder 3"/>
+          <p:cNvSpPr>
+            <a:spLocks noGrp="1"/>
+          </p:cNvSpPr>
+          <p:nvPr>
+            <p:ph type="sldNum" idx="5" sz="quarter"/>
+          </p:nvPr>
+        </p:nvSpPr>
+        <p:spPr/>
+      </p:sp>
+    </p:spTree>
+  </p:cSld>
+  <p:clrMapOvr>
+    <a:masterClrMapping/>
+  </p:clrMapOvr>
+</p:notes>
+</file>
+
+<file path=ppt/notesSlides/notesSlide2.xml><?xml version="1.0" encoding="utf-8"?>
+<p:notes xmlns:a="http://schemas.openxmlformats.org/drawingml/2006/main" xmlns:p="http://schemas.openxmlformats.org/presentationml/2006/main" xmlns:r="http://schemas.openxmlformats.org/officeDocument/2006/relationships">
+  <p:cSld>
+    <p:spTree>
+      <p:nvGrpSpPr>
+        <p:cNvPr id="1" name=""/>
+        <p:cNvGrpSpPr/>
+        <p:nvPr/>
+      </p:nvGrpSpPr>
+      <p:grpSpPr>
+        <a:xfrm>
+          <a:off x="0" y="0"/>
+          <a:ext cx="0" cy="0"/>
+          <a:chOff x="0" y="0"/>
+          <a:chExt cx="0" cy="0"/>
+        </a:xfrm>
+      </p:grpSpPr>
+      <p:sp>
+        <p:nvSpPr>
+          <p:cNvPr id="2" name="Slide Image Placeholder 1"/>
+          <p:cNvSpPr>
+            <a:spLocks noGrp="1"/>
+          </p:cNvSpPr>
+          <p:nvPr>
+            <p:ph type="sldImg" idx="2"/>
+          </p:nvPr>
+        </p:nvSpPr>
+        <p:spPr/>
+      </p:sp>
+      <p:sp>
+        <p:nvSpPr>
+          <p:cNvPr id="3" name="Notes Placeholder 2"/>
+          <p:cNvSpPr>
+            <a:spLocks noGrp="1"/>
+          </p:cNvSpPr>
+          <p:nvPr>
+            <p:ph type="body" idx="3" sz="quarter"/>
+          </p:nvPr>
+        </p:nvSpPr>
+        <p:spPr/>
+        <p:txBody>
+          <a:bodyPr/>
+          <a:lstStyle/>
+          <a:p>
+            <a:r>
+              <a:t>UCIELL — El problema (1 min)</a:t>
+            </a:r>
+          </a:p>
+          <a:p/>
+          <a:p>
+            <a:r>
+              <a:t>Las clínicas chicas agendan por WhatsApp, teléfono e Instagram. Eso genera dos problemas. El primero: la gente no llega a su hora, y ese bloque se pierde. El segundo, y más grave: como no hay registro, la clínica no sabe cuántas horas pierde ni cuánto le cuesta. Frase para cerrar: un problema que no se mide, no se puede gestionar.</a:t>
+            </a:r>
+          </a:p>
+        </p:txBody>
+      </p:sp>
+      <p:sp>
+        <p:nvSpPr>
+          <p:cNvPr id="4" name="Slide Number Placeholder 3"/>
+          <p:cNvSpPr>
+            <a:spLocks noGrp="1"/>
+          </p:cNvSpPr>
+          <p:nvPr>
+            <p:ph type="sldNum" idx="5" sz="quarter"/>
+          </p:nvPr>
+        </p:nvSpPr>
+        <p:spPr/>
+      </p:sp>
+    </p:spTree>
+  </p:cSld>
+  <p:clrMapOvr>
+    <a:masterClrMapping/>
+  </p:clrMapOvr>
+</p:notes>
+</file>
+
+<file path=ppt/notesSlides/notesSlide3.xml><?xml version="1.0" encoding="utf-8"?>
+<p:notes xmlns:a="http://schemas.openxmlformats.org/drawingml/2006/main" xmlns:p="http://schemas.openxmlformats.org/presentationml/2006/main" xmlns:r="http://schemas.openxmlformats.org/officeDocument/2006/relationships">
+  <p:cSld>
+    <p:spTree>
+      <p:nvGrpSpPr>
+        <p:cNvPr id="1" name=""/>
+        <p:cNvGrpSpPr/>
+        <p:nvPr/>
+      </p:nvGrpSpPr>
+      <p:grpSpPr>
+        <a:xfrm>
+          <a:off x="0" y="0"/>
+          <a:ext cx="0" cy="0"/>
+          <a:chOff x="0" y="0"/>
+          <a:chExt cx="0" cy="0"/>
+        </a:xfrm>
+      </p:grpSpPr>
+      <p:sp>
+        <p:nvSpPr>
+          <p:cNvPr id="2" name="Slide Image Placeholder 1"/>
+          <p:cNvSpPr>
+            <a:spLocks noGrp="1"/>
+          </p:cNvSpPr>
+          <p:nvPr>
+            <p:ph type="sldImg" idx="2"/>
+          </p:nvPr>
+        </p:nvSpPr>
+        <p:spPr/>
+      </p:sp>
+      <p:sp>
+        <p:nvSpPr>
+          <p:cNvPr id="3" name="Notes Placeholder 2"/>
+          <p:cNvSpPr>
+            <a:spLocks noGrp="1"/>
+          </p:cNvSpPr>
+          <p:nvPr>
+            <p:ph type="body" idx="3" sz="quarter"/>
+          </p:nvPr>
+        </p:nvSpPr>
+        <p:spPr/>
+        <p:txBody>
+          <a:bodyPr/>
+          <a:lstStyle/>
+          <a:p>
+            <a:r>
+              <a:t>UCIELL — Contexto (45 s)</a:t>
+            </a:r>
+          </a:p>
+          <a:p/>
+          <a:p>
+            <a:r>
+              <a:t>Trabajamos con la Clínica Veterinaria Clan, en Lo Pinto, y con otras de Batuco. Son clínicas chicas, de equipo reducido, fuera del radio de las grandes cadenas. El sector es grande: 12,4 millones de mascotas con tutor en Chile, y las veterinarias crecieron 22% en la Región Metropolitana durante 2025.</a:t>
+            </a:r>
+          </a:p>
+        </p:txBody>
+      </p:sp>
+      <p:sp>
+        <p:nvSpPr>
+          <p:cNvPr id="4" name="Slide Number Placeholder 3"/>
+          <p:cNvSpPr>
+            <a:spLocks noGrp="1"/>
+          </p:cNvSpPr>
+          <p:nvPr>
+            <p:ph type="sldNum" idx="5" sz="quarter"/>
+          </p:nvPr>
+        </p:nvSpPr>
+        <p:spPr/>
+      </p:sp>
+    </p:spTree>
+  </p:cSld>
+  <p:clrMapOvr>
+    <a:masterClrMapping/>
+  </p:clrMapOvr>
+</p:notes>
+</file>
+
+<file path=ppt/notesSlides/notesSlide4.xml><?xml version="1.0" encoding="utf-8"?>
+<p:notes xmlns:a="http://schemas.openxmlformats.org/drawingml/2006/main" xmlns:p="http://schemas.openxmlformats.org/presentationml/2006/main" xmlns:r="http://schemas.openxmlformats.org/officeDocument/2006/relationships">
+  <p:cSld>
+    <p:spTree>
+      <p:nvGrpSpPr>
+        <p:cNvPr id="1" name=""/>
+        <p:cNvGrpSpPr/>
+        <p:nvPr/>
+      </p:nvGrpSpPr>
+      <p:grpSpPr>
+        <a:xfrm>
+          <a:off x="0" y="0"/>
+          <a:ext cx="0" cy="0"/>
+          <a:chOff x="0" y="0"/>
+          <a:chExt cx="0" cy="0"/>
+        </a:xfrm>
+      </p:grpSpPr>
+      <p:sp>
+        <p:nvSpPr>
+          <p:cNvPr id="2" name="Slide Image Placeholder 1"/>
+          <p:cNvSpPr>
+            <a:spLocks noGrp="1"/>
+          </p:cNvSpPr>
+          <p:nvPr>
+            <p:ph type="sldImg" idx="2"/>
+          </p:nvPr>
+        </p:nvSpPr>
+        <p:spPr/>
+      </p:sp>
+      <p:sp>
+        <p:nvSpPr>
+          <p:cNvPr id="3" name="Notes Placeholder 2"/>
+          <p:cNvSpPr>
+            <a:spLocks noGrp="1"/>
+          </p:cNvSpPr>
+          <p:nvPr>
+            <p:ph type="body" idx="3" sz="quarter"/>
+          </p:nvPr>
+        </p:nvSpPr>
+        <p:spPr/>
+        <p:txBody>
+          <a:bodyPr/>
+          <a:lstStyle/>
+          <a:p>
+            <a:r>
+              <a:t>UCIELL — El mercado (1 min)</a:t>
+            </a:r>
+          </a:p>
+          <a:p/>
+          <a:p>
+            <a:r>
+              <a:t>Revisamos lo que ya existe: Wirevet, GVET, VeteSoft y otras. El punto importante es la última columna: TODAS resuelven la inasistencia igual, mandando un recordatorio idéntico a todo el mundo. Ninguna distingue el riesgo de cada caso.</a:t>
+            </a:r>
+          </a:p>
+        </p:txBody>
+      </p:sp>
+      <p:sp>
+        <p:nvSpPr>
+          <p:cNvPr id="4" name="Slide Number Placeholder 3"/>
+          <p:cNvSpPr>
+            <a:spLocks noGrp="1"/>
+          </p:cNvSpPr>
+          <p:nvPr>
+            <p:ph type="sldNum" idx="5" sz="quarter"/>
+          </p:nvPr>
+        </p:nvSpPr>
+        <p:spPr/>
+      </p:sp>
+    </p:spTree>
+  </p:cSld>
+  <p:clrMapOvr>
+    <a:masterClrMapping/>
+  </p:clrMapOvr>
+</p:notes>
+</file>
+
+<file path=ppt/notesSlides/notesSlide5.xml><?xml version="1.0" encoding="utf-8"?>
+<p:notes xmlns:a="http://schemas.openxmlformats.org/drawingml/2006/main" xmlns:p="http://schemas.openxmlformats.org/presentationml/2006/main" xmlns:r="http://schemas.openxmlformats.org/officeDocument/2006/relationships">
+  <p:cSld>
+    <p:spTree>
+      <p:nvGrpSpPr>
+        <p:cNvPr id="1" name=""/>
+        <p:cNvGrpSpPr/>
+        <p:nvPr/>
+      </p:nvGrpSpPr>
+      <p:grpSpPr>
+        <a:xfrm>
+          <a:off x="0" y="0"/>
+          <a:ext cx="0" cy="0"/>
+          <a:chOff x="0" y="0"/>
+          <a:chExt cx="0" cy="0"/>
+        </a:xfrm>
+      </p:grpSpPr>
+      <p:sp>
+        <p:nvSpPr>
+          <p:cNvPr id="2" name="Slide Image Placeholder 1"/>
+          <p:cNvSpPr>
+            <a:spLocks noGrp="1"/>
+          </p:cNvSpPr>
+          <p:nvPr>
+            <p:ph type="sldImg" idx="2"/>
+          </p:nvPr>
+        </p:nvSpPr>
+        <p:spPr/>
+      </p:sp>
+      <p:sp>
+        <p:nvSpPr>
+          <p:cNvPr id="3" name="Notes Placeholder 2"/>
+          <p:cNvSpPr>
+            <a:spLocks noGrp="1"/>
+          </p:cNvSpPr>
+          <p:nvPr>
+            <p:ph type="body" idx="3" sz="quarter"/>
+          </p:nvPr>
+        </p:nvSpPr>
+        <p:spPr/>
+        <p:txBody>
+          <a:bodyPr/>
+          <a:lstStyle/>
+          <a:p>
+            <a:r>
+              <a:t>UCIELL — La brecha (1 min)</a:t>
+            </a:r>
+          </a:p>
+          <a:p/>
+          <a:p>
+            <a:r>
+              <a:t>Dos hallazgos. Primero: la tecnología existe, pero parte en 59.990 pesos mensuales y no llega a las clínicas chicas. Eso es una brecha de adopción, no de tecnología. Segundo, y es el que nos importa: nadie predice qué hora se va a perder. OJO: si preguntan, aclarar que no decimos que no existan apps veterinarias — sí existen.</a:t>
+            </a:r>
+          </a:p>
+        </p:txBody>
+      </p:sp>
+      <p:sp>
+        <p:nvSpPr>
+          <p:cNvPr id="4" name="Slide Number Placeholder 3"/>
+          <p:cNvSpPr>
+            <a:spLocks noGrp="1"/>
+          </p:cNvSpPr>
+          <p:nvPr>
+            <p:ph type="sldNum" idx="5" sz="quarter"/>
+          </p:nvPr>
+        </p:nvSpPr>
+        <p:spPr/>
+      </p:sp>
+    </p:spTree>
+  </p:cSld>
+  <p:clrMapOvr>
+    <a:masterClrMapping/>
+  </p:clrMapOvr>
+</p:notes>
+</file>
+
+<file path=ppt/notesSlides/notesSlide6.xml><?xml version="1.0" encoding="utf-8"?>
+<p:notes xmlns:a="http://schemas.openxmlformats.org/drawingml/2006/main" xmlns:p="http://schemas.openxmlformats.org/presentationml/2006/main" xmlns:r="http://schemas.openxmlformats.org/officeDocument/2006/relationships">
+  <p:cSld>
+    <p:spTree>
+      <p:nvGrpSpPr>
+        <p:cNvPr id="1" name=""/>
+        <p:cNvGrpSpPr/>
+        <p:nvPr/>
+      </p:nvGrpSpPr>
+      <p:grpSpPr>
+        <a:xfrm>
+          <a:off x="0" y="0"/>
+          <a:ext cx="0" cy="0"/>
+          <a:chOff x="0" y="0"/>
+          <a:chExt cx="0" cy="0"/>
+        </a:xfrm>
+      </p:grpSpPr>
+      <p:sp>
+        <p:nvSpPr>
+          <p:cNvPr id="2" name="Slide Image Placeholder 1"/>
+          <p:cNvSpPr>
+            <a:spLocks noGrp="1"/>
+          </p:cNvSpPr>
+          <p:nvPr>
+            <p:ph type="sldImg" idx="2"/>
+          </p:nvPr>
+        </p:nvSpPr>
+        <p:spPr/>
+      </p:sp>
+      <p:sp>
+        <p:nvSpPr>
+          <p:cNvPr id="3" name="Notes Placeholder 2"/>
+          <p:cNvSpPr>
+            <a:spLocks noGrp="1"/>
+          </p:cNvSpPr>
+          <p:nvPr>
+            <p:ph type="body" idx="3" sz="quarter"/>
+          </p:nvPr>
+        </p:nvSpPr>
+        <p:spPr/>
+        <p:txBody>
+          <a:bodyPr/>
+          <a:lstStyle/>
+          <a:p>
+            <a:r>
+              <a:t>KATALINA — Huellitas (1,5 min)</a:t>
+            </a:r>
+          </a:p>
+          <a:p/>
+          <a:p>
+            <a:r>
+              <a:t>Partimos de un sistema que ya teníamos funcionando: Huellitas, hecho en Django, con nueve módulos. Al analizarlo encontramos algo clave: el modelo de citas solo tiene tres estados, pendiente, completada y cancelada. NO existe 'no asistió'. Si el tutor no llega, la cita queda pendiente para siempre. El sistema gestiona la agenda pero no puede medir su pérdida. Ese es exactamente nuestro aporte. SI PREGUNTAN POR LA AUTORÍA: Huellitas lo desarrollé antes de esta asignatura junto a una colaboradora externa; está declarado en la sección 2.9 del informe. Lo del equipo es el módulo de riesgo de inasistencia.</a:t>
+            </a:r>
+          </a:p>
+        </p:txBody>
+      </p:sp>
+      <p:sp>
+        <p:nvSpPr>
+          <p:cNvPr id="4" name="Slide Number Placeholder 3"/>
+          <p:cNvSpPr>
+            <a:spLocks noGrp="1"/>
+          </p:cNvSpPr>
+          <p:nvPr>
+            <p:ph type="sldNum" idx="5" sz="quarter"/>
+          </p:nvPr>
+        </p:nvSpPr>
+        <p:spPr/>
+      </p:sp>
+    </p:spTree>
+  </p:cSld>
+  <p:clrMapOvr>
+    <a:masterClrMapping/>
+  </p:clrMapOvr>
+</p:notes>
+</file>
+
+<file path=ppt/notesSlides/notesSlide7.xml><?xml version="1.0" encoding="utf-8"?>
+<p:notes xmlns:a="http://schemas.openxmlformats.org/drawingml/2006/main" xmlns:p="http://schemas.openxmlformats.org/presentationml/2006/main" xmlns:r="http://schemas.openxmlformats.org/officeDocument/2006/relationships">
+  <p:cSld>
+    <p:spTree>
+      <p:nvGrpSpPr>
+        <p:cNvPr id="1" name=""/>
+        <p:cNvGrpSpPr/>
+        <p:nvPr/>
+      </p:nvGrpSpPr>
+      <p:grpSpPr>
+        <a:xfrm>
+          <a:off x="0" y="0"/>
+          <a:ext cx="0" cy="0"/>
+          <a:chOff x="0" y="0"/>
+          <a:chExt cx="0" cy="0"/>
+        </a:xfrm>
+      </p:grpSpPr>
+      <p:sp>
+        <p:nvSpPr>
+          <p:cNvPr id="2" name="Slide Image Placeholder 1"/>
+          <p:cNvSpPr>
+            <a:spLocks noGrp="1"/>
+          </p:cNvSpPr>
+          <p:nvPr>
+            <p:ph type="sldImg" idx="2"/>
+          </p:nvPr>
+        </p:nvSpPr>
+        <p:spPr/>
+      </p:sp>
+      <p:sp>
+        <p:nvSpPr>
+          <p:cNvPr id="3" name="Notes Placeholder 2"/>
+          <p:cNvSpPr>
+            <a:spLocks noGrp="1"/>
+          </p:cNvSpPr>
+          <p:nvPr>
+            <p:ph type="body" idx="3" sz="quarter"/>
+          </p:nvPr>
+        </p:nvSpPr>
+        <p:spPr/>
+        <p:txBody>
+          <a:bodyPr/>
+          <a:lstStyle/>
+          <a:p>
+            <a:r>
+              <a:t>KATALINA — La innovación (1 min)</a:t>
+            </a:r>
+          </a:p>
+          <a:p/>
+          <a:p>
+            <a:r>
+              <a:t>Acá está el corazón del proyecto. Hoy el mercado es reactivo: manda un recordatorio igual para todos. Nosotras calculamos el riesgo de cada hora antes de que llegue el día, usando el historial del tutor, la anticipación de la reserva, el día y el tipo de atención. Lo que hacemos es traer a las veterinarias los modelos de predicción de inasistencia que en salud humana ya están validados.</a:t>
+            </a:r>
+          </a:p>
+        </p:txBody>
+      </p:sp>
+      <p:sp>
+        <p:nvSpPr>
+          <p:cNvPr id="4" name="Slide Number Placeholder 3"/>
+          <p:cNvSpPr>
+            <a:spLocks noGrp="1"/>
+          </p:cNvSpPr>
+          <p:nvPr>
+            <p:ph type="sldNum" idx="5" sz="quarter"/>
+          </p:nvPr>
+        </p:nvSpPr>
+        <p:spPr/>
+      </p:sp>
+    </p:spTree>
+  </p:cSld>
+  <p:clrMapOvr>
+    <a:masterClrMapping/>
+  </p:clrMapOvr>
+</p:notes>
+</file>
+
+<file path=ppt/notesSlides/notesSlide8.xml><?xml version="1.0" encoding="utf-8"?>
+<p:notes xmlns:a="http://schemas.openxmlformats.org/drawingml/2006/main" xmlns:p="http://schemas.openxmlformats.org/presentationml/2006/main" xmlns:r="http://schemas.openxmlformats.org/officeDocument/2006/relationships">
+  <p:cSld>
+    <p:spTree>
+      <p:nvGrpSpPr>
+        <p:cNvPr id="1" name=""/>
+        <p:cNvGrpSpPr/>
+        <p:nvPr/>
+      </p:nvGrpSpPr>
+      <p:grpSpPr>
+        <a:xfrm>
+          <a:off x="0" y="0"/>
+          <a:ext cx="0" cy="0"/>
+          <a:chOff x="0" y="0"/>
+          <a:chExt cx="0" cy="0"/>
+        </a:xfrm>
+      </p:grpSpPr>
+      <p:sp>
+        <p:nvSpPr>
+          <p:cNvPr id="2" name="Slide Image Placeholder 1"/>
+          <p:cNvSpPr>
+            <a:spLocks noGrp="1"/>
+          </p:cNvSpPr>
+          <p:nvPr>
+            <p:ph type="sldImg" idx="2"/>
+          </p:nvPr>
+        </p:nvSpPr>
+        <p:spPr/>
+      </p:sp>
+      <p:sp>
+        <p:nvSpPr>
+          <p:cNvPr id="3" name="Notes Placeholder 2"/>
+          <p:cNvSpPr>
+            <a:spLocks noGrp="1"/>
+          </p:cNvSpPr>
+          <p:nvPr>
+            <p:ph type="body" idx="3" sz="quarter"/>
+          </p:nvPr>
+        </p:nvSpPr>
+        <p:spPr/>
+        <p:txBody>
+          <a:bodyPr/>
+          <a:lstStyle/>
+          <a:p>
+            <a:r>
+              <a:t>KATALINA — La solución (1 min)</a:t>
+            </a:r>
+          </a:p>
+          <a:p/>
+          <a:p>
+            <a:r>
+              <a:t>Cinco etapas, y el orden importa. Primero formalizamos el proceso, después estructuramos los datos, después medimos, recién ahí predecimos, y finalmente recomendamos qué hacer. La frase: primero lo hacemos medible, después lo hacemos predecible.</a:t>
+            </a:r>
+          </a:p>
+        </p:txBody>
+      </p:sp>
+      <p:sp>
+        <p:nvSpPr>
+          <p:cNvPr id="4" name="Slide Number Placeholder 3"/>
+          <p:cNvSpPr>
+            <a:spLocks noGrp="1"/>
+          </p:cNvSpPr>
+          <p:nvPr>
+            <p:ph type="sldNum" idx="5" sz="quarter"/>
+          </p:nvPr>
+        </p:nvSpPr>
+        <p:spPr/>
+      </p:sp>
+    </p:spTree>
+  </p:cSld>
+  <p:clrMapOvr>
+    <a:masterClrMapping/>
+  </p:clrMapOvr>
+</p:notes>
+</file>
+
+<file path=ppt/notesSlides/notesSlide9.xml><?xml version="1.0" encoding="utf-8"?>
+<p:notes xmlns:a="http://schemas.openxmlformats.org/drawingml/2006/main" xmlns:p="http://schemas.openxmlformats.org/presentationml/2006/main" xmlns:r="http://schemas.openxmlformats.org/officeDocument/2006/relationships">
+  <p:cSld>
+    <p:spTree>
+      <p:nvGrpSpPr>
+        <p:cNvPr id="1" name=""/>
+        <p:cNvGrpSpPr/>
+        <p:nvPr/>
+      </p:nvGrpSpPr>
+      <p:grpSpPr>
+        <a:xfrm>
+          <a:off x="0" y="0"/>
+          <a:ext cx="0" cy="0"/>
+          <a:chOff x="0" y="0"/>
+          <a:chExt cx="0" cy="0"/>
+        </a:xfrm>
+      </p:grpSpPr>
+      <p:sp>
+        <p:nvSpPr>
+          <p:cNvPr id="2" name="Slide Image Placeholder 1"/>
+          <p:cNvSpPr>
+            <a:spLocks noGrp="1"/>
+          </p:cNvSpPr>
+          <p:nvPr>
+            <p:ph type="sldImg" idx="2"/>
+          </p:nvPr>
+        </p:nvSpPr>
+        <p:spPr/>
+      </p:sp>
+      <p:sp>
+        <p:nvSpPr>
+          <p:cNvPr id="3" name="Notes Placeholder 2"/>
+          <p:cNvSpPr>
+            <a:spLocks noGrp="1"/>
+          </p:cNvSpPr>
+          <p:nvPr>
+            <p:ph type="body" idx="3" sz="quarter"/>
+          </p:nvPr>
+        </p:nvSpPr>
+        <p:spPr/>
+        <p:txBody>
+          <a:bodyPr/>
+          <a:lstStyle/>
+          <a:p>
+            <a:r>
+              <a:t>KATALINA — Alcance comprometido (1 min)</a:t>
+            </a:r>
+          </a:p>
+          <a:p/>
+          <a:p>
+            <a:r>
+              <a:t>Esta lámina es para dejar cerrado el alcance, como pidió el profesor. A la izquierda lo que nos comprometemos a entregar. A la derecha lo que dejamos explícitamente fuera: la app móvil se entrega como prototipo, no construida, y el machine learning es una mejora opcional. El modelo base de riesgo va en SQL, así que el proyecto se completa igual aunque esa parte no alcance.</a:t>
+            </a:r>
+          </a:p>
+        </p:txBody>
+      </p:sp>
+      <p:sp>
+        <p:nvSpPr>
+          <p:cNvPr id="4" name="Slide Number Placeholder 3"/>
+          <p:cNvSpPr>
+            <a:spLocks noGrp="1"/>
+          </p:cNvSpPr>
+          <p:nvPr>
+            <p:ph type="sldNum" idx="5" sz="quarter"/>
+          </p:nvPr>
+        </p:nvSpPr>
+        <p:spPr/>
+      </p:sp>
+    </p:spTree>
+  </p:cSld>
+  <p:clrMapOvr>
+    <a:masterClrMapping/>
+  </p:clrMapOvr>
+</p:notes>
 </file>
 
 <file path=ppt/slideLayouts/slideLayout1.xml><?xml version="1.0" encoding="utf-8"?>
@@ -3348,7 +5067,7 @@
                 </a:solidFill>
                 <a:latin typeface="Calibri"/>
               </a:rPr>
-              <a:t>Capstone PTY4614 · Definición de Proyecto APT — Fase 1</a:t>
+              <a:t>Capstone PTY4614 · Evaluación 1 · Presentación de proyecto</a:t>
             </a:r>
           </a:p>
           <a:p>
@@ -3380,7 +5099,7 @@
                 </a:solidFill>
                 <a:latin typeface="Calibri"/>
               </a:rPr>
-              <a:t>Docente: Juan Alberto Gana Reyes  ·  Sede Plaza Norte  ·  Agosto 2026</a:t>
+              <a:t>Docente: Juan Alberto Gana Reyes  ·  Sede Plaza Norte  ·  Septiembre 2026</a:t>
             </a:r>
           </a:p>
         </p:txBody>
@@ -12453,7 +14172,1553 @@
                 </a:solidFill>
                 <a:latin typeface="Calibri"/>
               </a:rPr>
-              <a:t>Capstone PTY4614 · Fase 1 · Agosto 2026</a:t>
+              <a:t>Capstone PTY4614 · Evaluación 1 · Septiembre 2026</a:t>
+            </a:r>
+          </a:p>
+        </p:txBody>
+      </p:sp>
+    </p:spTree>
+  </p:cSld>
+  <p:clrMapOvr>
+    <a:masterClrMapping/>
+  </p:clrMapOvr>
+</p:sld>
+</file>
+
+<file path=ppt/slides/slide18.xml><?xml version="1.0" encoding="utf-8"?>
+<p:sld xmlns:a="http://schemas.openxmlformats.org/drawingml/2006/main" xmlns:p="http://schemas.openxmlformats.org/presentationml/2006/main" xmlns:r="http://schemas.openxmlformats.org/officeDocument/2006/relationships">
+  <p:cSld>
+    <p:spTree>
+      <p:nvGrpSpPr>
+        <p:cNvPr id="1" name=""/>
+        <p:cNvGrpSpPr/>
+        <p:nvPr/>
+      </p:nvGrpSpPr>
+      <p:grpSpPr/>
+      <p:sp>
+        <p:nvSpPr>
+          <p:cNvPr id="2" name="Rectangle 1"/>
+          <p:cNvSpPr/>
+          <p:nvPr/>
+        </p:nvSpPr>
+        <p:spPr>
+          <a:xfrm>
+            <a:off x="0" y="0"/>
+            <a:ext cx="12191695" cy="6858000"/>
+          </a:xfrm>
+          <a:prstGeom prst="rect">
+            <a:avLst/>
+          </a:prstGeom>
+          <a:solidFill>
+            <a:srgbClr val="FFFFFF"/>
+          </a:solidFill>
+          <a:ln>
+            <a:noFill/>
+          </a:ln>
+          <a:effectLst/>
+        </p:spPr>
+        <p:style>
+          <a:lnRef idx="1">
+            <a:schemeClr val="accent1"/>
+          </a:lnRef>
+          <a:fillRef idx="3">
+            <a:schemeClr val="accent1"/>
+          </a:fillRef>
+          <a:effectRef idx="2">
+            <a:schemeClr val="accent1"/>
+          </a:effectRef>
+          <a:fontRef idx="minor">
+            <a:schemeClr val="lt1"/>
+          </a:fontRef>
+        </p:style>
+        <p:txBody>
+          <a:bodyPr rtlCol="0" anchor="ctr"/>
+          <a:lstStyle/>
+          <a:p>
+            <a:pPr algn="ctr"/>
+          </a:p>
+        </p:txBody>
+      </p:sp>
+      <p:sp>
+        <p:nvSpPr>
+          <p:cNvPr id="3" name="Rectangle 2"/>
+          <p:cNvSpPr/>
+          <p:nvPr/>
+        </p:nvSpPr>
+        <p:spPr>
+          <a:xfrm>
+            <a:off x="0" y="0"/>
+            <a:ext cx="12191695" cy="1143000"/>
+          </a:xfrm>
+          <a:prstGeom prst="rect">
+            <a:avLst/>
+          </a:prstGeom>
+          <a:solidFill>
+            <a:srgbClr val="1F3A5F"/>
+          </a:solidFill>
+          <a:ln>
+            <a:noFill/>
+          </a:ln>
+          <a:effectLst/>
+        </p:spPr>
+        <p:style>
+          <a:lnRef idx="1">
+            <a:schemeClr val="accent1"/>
+          </a:lnRef>
+          <a:fillRef idx="3">
+            <a:schemeClr val="accent1"/>
+          </a:fillRef>
+          <a:effectRef idx="2">
+            <a:schemeClr val="accent1"/>
+          </a:effectRef>
+          <a:fontRef idx="minor">
+            <a:schemeClr val="lt1"/>
+          </a:fontRef>
+        </p:style>
+        <p:txBody>
+          <a:bodyPr rtlCol="0" anchor="ctr"/>
+          <a:lstStyle/>
+          <a:p>
+            <a:pPr algn="ctr"/>
+          </a:p>
+        </p:txBody>
+      </p:sp>
+      <p:sp>
+        <p:nvSpPr>
+          <p:cNvPr id="4" name="TextBox 3"/>
+          <p:cNvSpPr txBox="1"/>
+          <p:nvPr/>
+        </p:nvSpPr>
+        <p:spPr>
+          <a:xfrm>
+            <a:off x="548640" y="256032"/>
+            <a:ext cx="10241280" cy="640080"/>
+          </a:xfrm>
+          <a:prstGeom prst="rect">
+            <a:avLst/>
+          </a:prstGeom>
+          <a:noFill/>
+        </p:spPr>
+        <p:txBody>
+          <a:bodyPr wrap="square" anchor="t">
+            <a:spAutoFit/>
+          </a:bodyPr>
+          <a:lstStyle/>
+          <a:p>
+            <a:pPr algn="l">
+              <a:spcAft>
+                <a:spcPts val="600"/>
+              </a:spcAft>
+            </a:pPr>
+            <a:r>
+              <a:rPr sz="2700" b="1" i="0">
+                <a:solidFill>
+                  <a:srgbClr val="FFFFFF"/>
+                </a:solidFill>
+                <a:latin typeface="Calibri"/>
+              </a:rPr>
+              <a:t>Alcance comprometido</a:t>
+            </a:r>
+          </a:p>
+        </p:txBody>
+      </p:sp>
+      <p:sp>
+        <p:nvSpPr>
+          <p:cNvPr id="5" name="TextBox 4"/>
+          <p:cNvSpPr txBox="1"/>
+          <p:nvPr/>
+        </p:nvSpPr>
+        <p:spPr>
+          <a:xfrm>
+            <a:off x="11247120" y="347472"/>
+            <a:ext cx="640080" cy="457200"/>
+          </a:xfrm>
+          <a:prstGeom prst="rect">
+            <a:avLst/>
+          </a:prstGeom>
+          <a:noFill/>
+        </p:spPr>
+        <p:txBody>
+          <a:bodyPr wrap="square" anchor="t">
+            <a:spAutoFit/>
+          </a:bodyPr>
+          <a:lstStyle/>
+          <a:p>
+            <a:pPr algn="r">
+              <a:spcAft>
+                <a:spcPts val="600"/>
+              </a:spcAft>
+            </a:pPr>
+            <a:r>
+              <a:rPr sz="1400" b="0" i="0">
+                <a:solidFill>
+                  <a:srgbClr val="8FA8C4"/>
+                </a:solidFill>
+                <a:latin typeface="Calibri"/>
+              </a:rPr>
+              <a:t>9</a:t>
+            </a:r>
+          </a:p>
+        </p:txBody>
+      </p:sp>
+      <p:sp>
+        <p:nvSpPr>
+          <p:cNvPr id="6" name="TextBox 5"/>
+          <p:cNvSpPr txBox="1"/>
+          <p:nvPr/>
+        </p:nvSpPr>
+        <p:spPr>
+          <a:xfrm>
+            <a:off x="548640" y="1325880"/>
+            <a:ext cx="11064240" cy="457200"/>
+          </a:xfrm>
+          <a:prstGeom prst="rect">
+            <a:avLst/>
+          </a:prstGeom>
+          <a:noFill/>
+        </p:spPr>
+        <p:txBody>
+          <a:bodyPr wrap="square" anchor="t">
+            <a:spAutoFit/>
+          </a:bodyPr>
+          <a:lstStyle/>
+          <a:p>
+            <a:pPr algn="l">
+              <a:spcAft>
+                <a:spcPts val="600"/>
+              </a:spcAft>
+            </a:pPr>
+            <a:r>
+              <a:rPr sz="1500" b="0" i="1">
+                <a:solidFill>
+                  <a:srgbClr val="2E5C8A"/>
+                </a:solidFill>
+                <a:latin typeface="Calibri"/>
+              </a:rPr>
+              <a:t>Qué entregamos en este proyecto y qué queda declarado fuera</a:t>
+            </a:r>
+          </a:p>
+        </p:txBody>
+      </p:sp>
+      <p:sp>
+        <p:nvSpPr>
+          <p:cNvPr id="7" name="Rectangle 6"/>
+          <p:cNvSpPr/>
+          <p:nvPr/>
+        </p:nvSpPr>
+        <p:spPr>
+          <a:xfrm>
+            <a:off x="548640" y="1965960"/>
+            <a:ext cx="5394960" cy="3931920"/>
+          </a:xfrm>
+          <a:prstGeom prst="rect">
+            <a:avLst/>
+          </a:prstGeom>
+          <a:solidFill>
+            <a:srgbClr val="F4F7FA"/>
+          </a:solidFill>
+          <a:ln>
+            <a:noFill/>
+          </a:ln>
+          <a:effectLst/>
+        </p:spPr>
+        <p:style>
+          <a:lnRef idx="1">
+            <a:schemeClr val="accent1"/>
+          </a:lnRef>
+          <a:fillRef idx="3">
+            <a:schemeClr val="accent1"/>
+          </a:fillRef>
+          <a:effectRef idx="2">
+            <a:schemeClr val="accent1"/>
+          </a:effectRef>
+          <a:fontRef idx="minor">
+            <a:schemeClr val="lt1"/>
+          </a:fontRef>
+        </p:style>
+        <p:txBody>
+          <a:bodyPr rtlCol="0" anchor="ctr"/>
+          <a:lstStyle/>
+          <a:p>
+            <a:pPr algn="ctr"/>
+          </a:p>
+        </p:txBody>
+      </p:sp>
+      <p:sp>
+        <p:nvSpPr>
+          <p:cNvPr id="8" name="Rectangle 7"/>
+          <p:cNvSpPr/>
+          <p:nvPr/>
+        </p:nvSpPr>
+        <p:spPr>
+          <a:xfrm>
+            <a:off x="548640" y="1965960"/>
+            <a:ext cx="5394960" cy="82296"/>
+          </a:xfrm>
+          <a:prstGeom prst="rect">
+            <a:avLst/>
+          </a:prstGeom>
+          <a:solidFill>
+            <a:srgbClr val="4F8A63"/>
+          </a:solidFill>
+          <a:ln>
+            <a:noFill/>
+          </a:ln>
+          <a:effectLst/>
+        </p:spPr>
+        <p:style>
+          <a:lnRef idx="1">
+            <a:schemeClr val="accent1"/>
+          </a:lnRef>
+          <a:fillRef idx="3">
+            <a:schemeClr val="accent1"/>
+          </a:fillRef>
+          <a:effectRef idx="2">
+            <a:schemeClr val="accent1"/>
+          </a:effectRef>
+          <a:fontRef idx="minor">
+            <a:schemeClr val="lt1"/>
+          </a:fontRef>
+        </p:style>
+        <p:txBody>
+          <a:bodyPr rtlCol="0" anchor="ctr"/>
+          <a:lstStyle/>
+          <a:p>
+            <a:pPr algn="ctr"/>
+          </a:p>
+        </p:txBody>
+      </p:sp>
+      <p:sp>
+        <p:nvSpPr>
+          <p:cNvPr id="9" name="TextBox 8"/>
+          <p:cNvSpPr txBox="1"/>
+          <p:nvPr/>
+        </p:nvSpPr>
+        <p:spPr>
+          <a:xfrm>
+            <a:off x="822960" y="2148840"/>
+            <a:ext cx="4846320" cy="411480"/>
+          </a:xfrm>
+          <a:prstGeom prst="rect">
+            <a:avLst/>
+          </a:prstGeom>
+          <a:noFill/>
+        </p:spPr>
+        <p:txBody>
+          <a:bodyPr wrap="square" anchor="t">
+            <a:spAutoFit/>
+          </a:bodyPr>
+          <a:lstStyle/>
+          <a:p>
+            <a:pPr algn="l">
+              <a:spcAft>
+                <a:spcPts val="600"/>
+              </a:spcAft>
+            </a:pPr>
+            <a:r>
+              <a:rPr sz="1700" b="1" i="0">
+                <a:solidFill>
+                  <a:srgbClr val="4F8A63"/>
+                </a:solidFill>
+                <a:latin typeface="Calibri"/>
+              </a:rPr>
+              <a:t>SÍ · Comprometido</a:t>
+            </a:r>
+          </a:p>
+        </p:txBody>
+      </p:sp>
+      <p:sp>
+        <p:nvSpPr>
+          <p:cNvPr id="10" name="Rectangle 9"/>
+          <p:cNvSpPr/>
+          <p:nvPr/>
+        </p:nvSpPr>
+        <p:spPr>
+          <a:xfrm>
+            <a:off x="868680" y="2862072"/>
+            <a:ext cx="118872" cy="118872"/>
+          </a:xfrm>
+          <a:prstGeom prst="rect">
+            <a:avLst/>
+          </a:prstGeom>
+          <a:solidFill>
+            <a:srgbClr val="4F8A63"/>
+          </a:solidFill>
+          <a:ln>
+            <a:noFill/>
+          </a:ln>
+          <a:effectLst/>
+        </p:spPr>
+        <p:style>
+          <a:lnRef idx="1">
+            <a:schemeClr val="accent1"/>
+          </a:lnRef>
+          <a:fillRef idx="3">
+            <a:schemeClr val="accent1"/>
+          </a:fillRef>
+          <a:effectRef idx="2">
+            <a:schemeClr val="accent1"/>
+          </a:effectRef>
+          <a:fontRef idx="minor">
+            <a:schemeClr val="lt1"/>
+          </a:fontRef>
+        </p:style>
+        <p:txBody>
+          <a:bodyPr rtlCol="0" anchor="ctr"/>
+          <a:lstStyle/>
+          <a:p>
+            <a:pPr algn="ctr"/>
+          </a:p>
+        </p:txBody>
+      </p:sp>
+      <p:sp>
+        <p:nvSpPr>
+          <p:cNvPr id="11" name="TextBox 10"/>
+          <p:cNvSpPr txBox="1"/>
+          <p:nvPr/>
+        </p:nvSpPr>
+        <p:spPr>
+          <a:xfrm>
+            <a:off x="1170432" y="2743200"/>
+            <a:ext cx="4572000" cy="457200"/>
+          </a:xfrm>
+          <a:prstGeom prst="rect">
+            <a:avLst/>
+          </a:prstGeom>
+          <a:noFill/>
+        </p:spPr>
+        <p:txBody>
+          <a:bodyPr wrap="square" anchor="t">
+            <a:spAutoFit/>
+          </a:bodyPr>
+          <a:lstStyle/>
+          <a:p>
+            <a:pPr algn="l">
+              <a:spcAft>
+                <a:spcPts val="600"/>
+              </a:spcAft>
+            </a:pPr>
+            <a:r>
+              <a:rPr sz="1350" b="0" i="0">
+                <a:solidFill>
+                  <a:srgbClr val="22303C"/>
+                </a:solidFill>
+                <a:latin typeface="Calibri"/>
+              </a:rPr>
+              <a:t>Registro de la inasistencia en el modelo de datos</a:t>
+            </a:r>
+          </a:p>
+        </p:txBody>
+      </p:sp>
+      <p:sp>
+        <p:nvSpPr>
+          <p:cNvPr id="12" name="Rectangle 11"/>
+          <p:cNvSpPr/>
+          <p:nvPr/>
+        </p:nvSpPr>
+        <p:spPr>
+          <a:xfrm>
+            <a:off x="868680" y="3364991"/>
+            <a:ext cx="118872" cy="118872"/>
+          </a:xfrm>
+          <a:prstGeom prst="rect">
+            <a:avLst/>
+          </a:prstGeom>
+          <a:solidFill>
+            <a:srgbClr val="4F8A63"/>
+          </a:solidFill>
+          <a:ln>
+            <a:noFill/>
+          </a:ln>
+          <a:effectLst/>
+        </p:spPr>
+        <p:style>
+          <a:lnRef idx="1">
+            <a:schemeClr val="accent1"/>
+          </a:lnRef>
+          <a:fillRef idx="3">
+            <a:schemeClr val="accent1"/>
+          </a:fillRef>
+          <a:effectRef idx="2">
+            <a:schemeClr val="accent1"/>
+          </a:effectRef>
+          <a:fontRef idx="minor">
+            <a:schemeClr val="lt1"/>
+          </a:fontRef>
+        </p:style>
+        <p:txBody>
+          <a:bodyPr rtlCol="0" anchor="ctr"/>
+          <a:lstStyle/>
+          <a:p>
+            <a:pPr algn="ctr"/>
+          </a:p>
+        </p:txBody>
+      </p:sp>
+      <p:sp>
+        <p:nvSpPr>
+          <p:cNvPr id="13" name="TextBox 12"/>
+          <p:cNvSpPr txBox="1"/>
+          <p:nvPr/>
+        </p:nvSpPr>
+        <p:spPr>
+          <a:xfrm>
+            <a:off x="1170432" y="3246120"/>
+            <a:ext cx="4572000" cy="457200"/>
+          </a:xfrm>
+          <a:prstGeom prst="rect">
+            <a:avLst/>
+          </a:prstGeom>
+          <a:noFill/>
+        </p:spPr>
+        <p:txBody>
+          <a:bodyPr wrap="square" anchor="t">
+            <a:spAutoFit/>
+          </a:bodyPr>
+          <a:lstStyle/>
+          <a:p>
+            <a:pPr algn="l">
+              <a:spcAft>
+                <a:spcPts val="600"/>
+              </a:spcAft>
+            </a:pPr>
+            <a:r>
+              <a:rPr sz="1350" b="0" i="0">
+                <a:solidFill>
+                  <a:srgbClr val="22303C"/>
+                </a:solidFill>
+                <a:latin typeface="Calibri"/>
+              </a:rPr>
+              <a:t>Catálogo de tipos de atención, con duración y valor</a:t>
+            </a:r>
+          </a:p>
+        </p:txBody>
+      </p:sp>
+      <p:sp>
+        <p:nvSpPr>
+          <p:cNvPr id="14" name="Rectangle 13"/>
+          <p:cNvSpPr/>
+          <p:nvPr/>
+        </p:nvSpPr>
+        <p:spPr>
+          <a:xfrm>
+            <a:off x="868680" y="3867911"/>
+            <a:ext cx="118872" cy="118872"/>
+          </a:xfrm>
+          <a:prstGeom prst="rect">
+            <a:avLst/>
+          </a:prstGeom>
+          <a:solidFill>
+            <a:srgbClr val="4F8A63"/>
+          </a:solidFill>
+          <a:ln>
+            <a:noFill/>
+          </a:ln>
+          <a:effectLst/>
+        </p:spPr>
+        <p:style>
+          <a:lnRef idx="1">
+            <a:schemeClr val="accent1"/>
+          </a:lnRef>
+          <a:fillRef idx="3">
+            <a:schemeClr val="accent1"/>
+          </a:fillRef>
+          <a:effectRef idx="2">
+            <a:schemeClr val="accent1"/>
+          </a:effectRef>
+          <a:fontRef idx="minor">
+            <a:schemeClr val="lt1"/>
+          </a:fontRef>
+        </p:style>
+        <p:txBody>
+          <a:bodyPr rtlCol="0" anchor="ctr"/>
+          <a:lstStyle/>
+          <a:p>
+            <a:pPr algn="ctr"/>
+          </a:p>
+        </p:txBody>
+      </p:sp>
+      <p:sp>
+        <p:nvSpPr>
+          <p:cNvPr id="15" name="TextBox 14"/>
+          <p:cNvSpPr txBox="1"/>
+          <p:nvPr/>
+        </p:nvSpPr>
+        <p:spPr>
+          <a:xfrm>
+            <a:off x="1170432" y="3749039"/>
+            <a:ext cx="4572000" cy="457200"/>
+          </a:xfrm>
+          <a:prstGeom prst="rect">
+            <a:avLst/>
+          </a:prstGeom>
+          <a:noFill/>
+        </p:spPr>
+        <p:txBody>
+          <a:bodyPr wrap="square" anchor="t">
+            <a:spAutoFit/>
+          </a:bodyPr>
+          <a:lstStyle/>
+          <a:p>
+            <a:pPr algn="l">
+              <a:spcAft>
+                <a:spcPts val="600"/>
+              </a:spcAft>
+            </a:pPr>
+            <a:r>
+              <a:rPr sz="1350" b="0" i="0">
+                <a:solidFill>
+                  <a:srgbClr val="22303C"/>
+                </a:solidFill>
+                <a:latin typeface="Calibri"/>
+              </a:rPr>
+              <a:t>Indicadores de gestión e impacto económico</a:t>
+            </a:r>
+          </a:p>
+        </p:txBody>
+      </p:sp>
+      <p:sp>
+        <p:nvSpPr>
+          <p:cNvPr id="16" name="Rectangle 15"/>
+          <p:cNvSpPr/>
+          <p:nvPr/>
+        </p:nvSpPr>
+        <p:spPr>
+          <a:xfrm>
+            <a:off x="868680" y="4370832"/>
+            <a:ext cx="118872" cy="118872"/>
+          </a:xfrm>
+          <a:prstGeom prst="rect">
+            <a:avLst/>
+          </a:prstGeom>
+          <a:solidFill>
+            <a:srgbClr val="4F8A63"/>
+          </a:solidFill>
+          <a:ln>
+            <a:noFill/>
+          </a:ln>
+          <a:effectLst/>
+        </p:spPr>
+        <p:style>
+          <a:lnRef idx="1">
+            <a:schemeClr val="accent1"/>
+          </a:lnRef>
+          <a:fillRef idx="3">
+            <a:schemeClr val="accent1"/>
+          </a:fillRef>
+          <a:effectRef idx="2">
+            <a:schemeClr val="accent1"/>
+          </a:effectRef>
+          <a:fontRef idx="minor">
+            <a:schemeClr val="lt1"/>
+          </a:fontRef>
+        </p:style>
+        <p:txBody>
+          <a:bodyPr rtlCol="0" anchor="ctr"/>
+          <a:lstStyle/>
+          <a:p>
+            <a:pPr algn="ctr"/>
+          </a:p>
+        </p:txBody>
+      </p:sp>
+      <p:sp>
+        <p:nvSpPr>
+          <p:cNvPr id="17" name="TextBox 16"/>
+          <p:cNvSpPr txBox="1"/>
+          <p:nvPr/>
+        </p:nvSpPr>
+        <p:spPr>
+          <a:xfrm>
+            <a:off x="1170432" y="4251960"/>
+            <a:ext cx="4572000" cy="457200"/>
+          </a:xfrm>
+          <a:prstGeom prst="rect">
+            <a:avLst/>
+          </a:prstGeom>
+          <a:noFill/>
+        </p:spPr>
+        <p:txBody>
+          <a:bodyPr wrap="square" anchor="t">
+            <a:spAutoFit/>
+          </a:bodyPr>
+          <a:lstStyle/>
+          <a:p>
+            <a:pPr algn="l">
+              <a:spcAft>
+                <a:spcPts val="600"/>
+              </a:spcAft>
+            </a:pPr>
+            <a:r>
+              <a:rPr sz="1350" b="0" i="0">
+                <a:solidFill>
+                  <a:srgbClr val="22303C"/>
+                </a:solidFill>
+                <a:latin typeface="Calibri"/>
+              </a:rPr>
+              <a:t>Modelo de puntuación de riesgo en SQL</a:t>
+            </a:r>
+          </a:p>
+        </p:txBody>
+      </p:sp>
+      <p:sp>
+        <p:nvSpPr>
+          <p:cNvPr id="18" name="Rectangle 17"/>
+          <p:cNvSpPr/>
+          <p:nvPr/>
+        </p:nvSpPr>
+        <p:spPr>
+          <a:xfrm>
+            <a:off x="868680" y="4873752"/>
+            <a:ext cx="118872" cy="118872"/>
+          </a:xfrm>
+          <a:prstGeom prst="rect">
+            <a:avLst/>
+          </a:prstGeom>
+          <a:solidFill>
+            <a:srgbClr val="4F8A63"/>
+          </a:solidFill>
+          <a:ln>
+            <a:noFill/>
+          </a:ln>
+          <a:effectLst/>
+        </p:spPr>
+        <p:style>
+          <a:lnRef idx="1">
+            <a:schemeClr val="accent1"/>
+          </a:lnRef>
+          <a:fillRef idx="3">
+            <a:schemeClr val="accent1"/>
+          </a:fillRef>
+          <a:effectRef idx="2">
+            <a:schemeClr val="accent1"/>
+          </a:effectRef>
+          <a:fontRef idx="minor">
+            <a:schemeClr val="lt1"/>
+          </a:fontRef>
+        </p:style>
+        <p:txBody>
+          <a:bodyPr rtlCol="0" anchor="ctr"/>
+          <a:lstStyle/>
+          <a:p>
+            <a:pPr algn="ctr"/>
+          </a:p>
+        </p:txBody>
+      </p:sp>
+      <p:sp>
+        <p:nvSpPr>
+          <p:cNvPr id="19" name="TextBox 18"/>
+          <p:cNvSpPr txBox="1"/>
+          <p:nvPr/>
+        </p:nvSpPr>
+        <p:spPr>
+          <a:xfrm>
+            <a:off x="1170432" y="4754880"/>
+            <a:ext cx="4572000" cy="457200"/>
+          </a:xfrm>
+          <a:prstGeom prst="rect">
+            <a:avLst/>
+          </a:prstGeom>
+          <a:noFill/>
+        </p:spPr>
+        <p:txBody>
+          <a:bodyPr wrap="square" anchor="t">
+            <a:spAutoFit/>
+          </a:bodyPr>
+          <a:lstStyle/>
+          <a:p>
+            <a:pPr algn="l">
+              <a:spcAft>
+                <a:spcPts val="600"/>
+              </a:spcAft>
+            </a:pPr>
+            <a:r>
+              <a:rPr sz="1350" b="0" i="0">
+                <a:solidFill>
+                  <a:srgbClr val="22303C"/>
+                </a:solidFill>
+                <a:latin typeface="Calibri"/>
+              </a:rPr>
+              <a:t>Tablero en Power BI con acción recomendada</a:t>
+            </a:r>
+          </a:p>
+        </p:txBody>
+      </p:sp>
+      <p:sp>
+        <p:nvSpPr>
+          <p:cNvPr id="20" name="Rectangle 19"/>
+          <p:cNvSpPr/>
+          <p:nvPr/>
+        </p:nvSpPr>
+        <p:spPr>
+          <a:xfrm>
+            <a:off x="868680" y="5376672"/>
+            <a:ext cx="118872" cy="118872"/>
+          </a:xfrm>
+          <a:prstGeom prst="rect">
+            <a:avLst/>
+          </a:prstGeom>
+          <a:solidFill>
+            <a:srgbClr val="4F8A63"/>
+          </a:solidFill>
+          <a:ln>
+            <a:noFill/>
+          </a:ln>
+          <a:effectLst/>
+        </p:spPr>
+        <p:style>
+          <a:lnRef idx="1">
+            <a:schemeClr val="accent1"/>
+          </a:lnRef>
+          <a:fillRef idx="3">
+            <a:schemeClr val="accent1"/>
+          </a:fillRef>
+          <a:effectRef idx="2">
+            <a:schemeClr val="accent1"/>
+          </a:effectRef>
+          <a:fontRef idx="minor">
+            <a:schemeClr val="lt1"/>
+          </a:fontRef>
+        </p:style>
+        <p:txBody>
+          <a:bodyPr rtlCol="0" anchor="ctr"/>
+          <a:lstStyle/>
+          <a:p>
+            <a:pPr algn="ctr"/>
+          </a:p>
+        </p:txBody>
+      </p:sp>
+      <p:sp>
+        <p:nvSpPr>
+          <p:cNvPr id="21" name="TextBox 20"/>
+          <p:cNvSpPr txBox="1"/>
+          <p:nvPr/>
+        </p:nvSpPr>
+        <p:spPr>
+          <a:xfrm>
+            <a:off x="1170432" y="5257800"/>
+            <a:ext cx="4572000" cy="457200"/>
+          </a:xfrm>
+          <a:prstGeom prst="rect">
+            <a:avLst/>
+          </a:prstGeom>
+          <a:noFill/>
+        </p:spPr>
+        <p:txBody>
+          <a:bodyPr wrap="square" anchor="t">
+            <a:spAutoFit/>
+          </a:bodyPr>
+          <a:lstStyle/>
+          <a:p>
+            <a:pPr algn="l">
+              <a:spcAft>
+                <a:spcPts val="600"/>
+              </a:spcAft>
+            </a:pPr>
+            <a:r>
+              <a:rPr sz="1350" b="0" i="0">
+                <a:solidFill>
+                  <a:srgbClr val="22303C"/>
+                </a:solidFill>
+                <a:latin typeface="Calibri"/>
+              </a:rPr>
+              <a:t>Plan de pruebas y validación con la clínica</a:t>
+            </a:r>
+          </a:p>
+        </p:txBody>
+      </p:sp>
+      <p:sp>
+        <p:nvSpPr>
+          <p:cNvPr id="22" name="Rectangle 21"/>
+          <p:cNvSpPr/>
+          <p:nvPr/>
+        </p:nvSpPr>
+        <p:spPr>
+          <a:xfrm>
+            <a:off x="6263640" y="1965960"/>
+            <a:ext cx="5394960" cy="3931920"/>
+          </a:xfrm>
+          <a:prstGeom prst="rect">
+            <a:avLst/>
+          </a:prstGeom>
+          <a:solidFill>
+            <a:srgbClr val="F4F7FA"/>
+          </a:solidFill>
+          <a:ln>
+            <a:noFill/>
+          </a:ln>
+          <a:effectLst/>
+        </p:spPr>
+        <p:style>
+          <a:lnRef idx="1">
+            <a:schemeClr val="accent1"/>
+          </a:lnRef>
+          <a:fillRef idx="3">
+            <a:schemeClr val="accent1"/>
+          </a:fillRef>
+          <a:effectRef idx="2">
+            <a:schemeClr val="accent1"/>
+          </a:effectRef>
+          <a:fontRef idx="minor">
+            <a:schemeClr val="lt1"/>
+          </a:fontRef>
+        </p:style>
+        <p:txBody>
+          <a:bodyPr rtlCol="0" anchor="ctr"/>
+          <a:lstStyle/>
+          <a:p>
+            <a:pPr algn="ctr"/>
+          </a:p>
+        </p:txBody>
+      </p:sp>
+      <p:sp>
+        <p:nvSpPr>
+          <p:cNvPr id="23" name="Rectangle 22"/>
+          <p:cNvSpPr/>
+          <p:nvPr/>
+        </p:nvSpPr>
+        <p:spPr>
+          <a:xfrm>
+            <a:off x="6263640" y="1965960"/>
+            <a:ext cx="5394960" cy="82296"/>
+          </a:xfrm>
+          <a:prstGeom prst="rect">
+            <a:avLst/>
+          </a:prstGeom>
+          <a:solidFill>
+            <a:srgbClr val="8A9AA8"/>
+          </a:solidFill>
+          <a:ln>
+            <a:noFill/>
+          </a:ln>
+          <a:effectLst/>
+        </p:spPr>
+        <p:style>
+          <a:lnRef idx="1">
+            <a:schemeClr val="accent1"/>
+          </a:lnRef>
+          <a:fillRef idx="3">
+            <a:schemeClr val="accent1"/>
+          </a:fillRef>
+          <a:effectRef idx="2">
+            <a:schemeClr val="accent1"/>
+          </a:effectRef>
+          <a:fontRef idx="minor">
+            <a:schemeClr val="lt1"/>
+          </a:fontRef>
+        </p:style>
+        <p:txBody>
+          <a:bodyPr rtlCol="0" anchor="ctr"/>
+          <a:lstStyle/>
+          <a:p>
+            <a:pPr algn="ctr"/>
+          </a:p>
+        </p:txBody>
+      </p:sp>
+      <p:sp>
+        <p:nvSpPr>
+          <p:cNvPr id="24" name="TextBox 23"/>
+          <p:cNvSpPr txBox="1"/>
+          <p:nvPr/>
+        </p:nvSpPr>
+        <p:spPr>
+          <a:xfrm>
+            <a:off x="6537960" y="2148840"/>
+            <a:ext cx="4846320" cy="411480"/>
+          </a:xfrm>
+          <a:prstGeom prst="rect">
+            <a:avLst/>
+          </a:prstGeom>
+          <a:noFill/>
+        </p:spPr>
+        <p:txBody>
+          <a:bodyPr wrap="square" anchor="t">
+            <a:spAutoFit/>
+          </a:bodyPr>
+          <a:lstStyle/>
+          <a:p>
+            <a:pPr algn="l">
+              <a:spcAft>
+                <a:spcPts val="600"/>
+              </a:spcAft>
+            </a:pPr>
+            <a:r>
+              <a:rPr sz="1700" b="1" i="0">
+                <a:solidFill>
+                  <a:srgbClr val="8A9AA8"/>
+                </a:solidFill>
+                <a:latin typeface="Calibri"/>
+              </a:rPr>
+              <a:t>NO · Fuera del alcance</a:t>
+            </a:r>
+          </a:p>
+        </p:txBody>
+      </p:sp>
+      <p:sp>
+        <p:nvSpPr>
+          <p:cNvPr id="25" name="Rectangle 24"/>
+          <p:cNvSpPr/>
+          <p:nvPr/>
+        </p:nvSpPr>
+        <p:spPr>
+          <a:xfrm>
+            <a:off x="6583680" y="2862072"/>
+            <a:ext cx="118872" cy="118872"/>
+          </a:xfrm>
+          <a:prstGeom prst="rect">
+            <a:avLst/>
+          </a:prstGeom>
+          <a:solidFill>
+            <a:srgbClr val="8A9AA8"/>
+          </a:solidFill>
+          <a:ln>
+            <a:noFill/>
+          </a:ln>
+          <a:effectLst/>
+        </p:spPr>
+        <p:style>
+          <a:lnRef idx="1">
+            <a:schemeClr val="accent1"/>
+          </a:lnRef>
+          <a:fillRef idx="3">
+            <a:schemeClr val="accent1"/>
+          </a:fillRef>
+          <a:effectRef idx="2">
+            <a:schemeClr val="accent1"/>
+          </a:effectRef>
+          <a:fontRef idx="minor">
+            <a:schemeClr val="lt1"/>
+          </a:fontRef>
+        </p:style>
+        <p:txBody>
+          <a:bodyPr rtlCol="0" anchor="ctr"/>
+          <a:lstStyle/>
+          <a:p>
+            <a:pPr algn="ctr"/>
+          </a:p>
+        </p:txBody>
+      </p:sp>
+      <p:sp>
+        <p:nvSpPr>
+          <p:cNvPr id="26" name="TextBox 25"/>
+          <p:cNvSpPr txBox="1"/>
+          <p:nvPr/>
+        </p:nvSpPr>
+        <p:spPr>
+          <a:xfrm>
+            <a:off x="6885432" y="2743200"/>
+            <a:ext cx="4572000" cy="365760"/>
+          </a:xfrm>
+          <a:prstGeom prst="rect">
+            <a:avLst/>
+          </a:prstGeom>
+          <a:noFill/>
+        </p:spPr>
+        <p:txBody>
+          <a:bodyPr wrap="square" anchor="t">
+            <a:spAutoFit/>
+          </a:bodyPr>
+          <a:lstStyle/>
+          <a:p>
+            <a:pPr algn="l">
+              <a:spcAft>
+                <a:spcPts val="600"/>
+              </a:spcAft>
+            </a:pPr>
+            <a:r>
+              <a:rPr sz="1350" b="0" i="0">
+                <a:solidFill>
+                  <a:srgbClr val="22303C"/>
+                </a:solidFill>
+                <a:latin typeface="Calibri"/>
+              </a:rPr>
+              <a:t>Construcción de la app móvil del tutor</a:t>
+            </a:r>
+          </a:p>
+        </p:txBody>
+      </p:sp>
+      <p:sp>
+        <p:nvSpPr>
+          <p:cNvPr id="27" name="TextBox 26"/>
+          <p:cNvSpPr txBox="1"/>
+          <p:nvPr/>
+        </p:nvSpPr>
+        <p:spPr>
+          <a:xfrm>
+            <a:off x="6885432" y="3035808"/>
+            <a:ext cx="4572000" cy="320040"/>
+          </a:xfrm>
+          <a:prstGeom prst="rect">
+            <a:avLst/>
+          </a:prstGeom>
+          <a:noFill/>
+        </p:spPr>
+        <p:txBody>
+          <a:bodyPr wrap="square" anchor="t">
+            <a:spAutoFit/>
+          </a:bodyPr>
+          <a:lstStyle/>
+          <a:p>
+            <a:pPr algn="l">
+              <a:spcAft>
+                <a:spcPts val="600"/>
+              </a:spcAft>
+            </a:pPr>
+            <a:r>
+              <a:rPr sz="1050" b="0" i="1">
+                <a:solidFill>
+                  <a:srgbClr val="8A9AA8"/>
+                </a:solidFill>
+                <a:latin typeface="Calibri"/>
+              </a:rPr>
+              <a:t>Se entrega como prototipo navegable</a:t>
+            </a:r>
+          </a:p>
+        </p:txBody>
+      </p:sp>
+      <p:sp>
+        <p:nvSpPr>
+          <p:cNvPr id="28" name="Rectangle 27"/>
+          <p:cNvSpPr/>
+          <p:nvPr/>
+        </p:nvSpPr>
+        <p:spPr>
+          <a:xfrm>
+            <a:off x="6583680" y="3611879"/>
+            <a:ext cx="118872" cy="118872"/>
+          </a:xfrm>
+          <a:prstGeom prst="rect">
+            <a:avLst/>
+          </a:prstGeom>
+          <a:solidFill>
+            <a:srgbClr val="8A9AA8"/>
+          </a:solidFill>
+          <a:ln>
+            <a:noFill/>
+          </a:ln>
+          <a:effectLst/>
+        </p:spPr>
+        <p:style>
+          <a:lnRef idx="1">
+            <a:schemeClr val="accent1"/>
+          </a:lnRef>
+          <a:fillRef idx="3">
+            <a:schemeClr val="accent1"/>
+          </a:fillRef>
+          <a:effectRef idx="2">
+            <a:schemeClr val="accent1"/>
+          </a:effectRef>
+          <a:fontRef idx="minor">
+            <a:schemeClr val="lt1"/>
+          </a:fontRef>
+        </p:style>
+        <p:txBody>
+          <a:bodyPr rtlCol="0" anchor="ctr"/>
+          <a:lstStyle/>
+          <a:p>
+            <a:pPr algn="ctr"/>
+          </a:p>
+        </p:txBody>
+      </p:sp>
+      <p:sp>
+        <p:nvSpPr>
+          <p:cNvPr id="29" name="TextBox 28"/>
+          <p:cNvSpPr txBox="1"/>
+          <p:nvPr/>
+        </p:nvSpPr>
+        <p:spPr>
+          <a:xfrm>
+            <a:off x="6885432" y="3493008"/>
+            <a:ext cx="4572000" cy="365760"/>
+          </a:xfrm>
+          <a:prstGeom prst="rect">
+            <a:avLst/>
+          </a:prstGeom>
+          <a:noFill/>
+        </p:spPr>
+        <p:txBody>
+          <a:bodyPr wrap="square" anchor="t">
+            <a:spAutoFit/>
+          </a:bodyPr>
+          <a:lstStyle/>
+          <a:p>
+            <a:pPr algn="l">
+              <a:spcAft>
+                <a:spcPts val="600"/>
+              </a:spcAft>
+            </a:pPr>
+            <a:r>
+              <a:rPr sz="1350" b="0" i="0">
+                <a:solidFill>
+                  <a:srgbClr val="22303C"/>
+                </a:solidFill>
+                <a:latin typeface="Calibri"/>
+              </a:rPr>
+              <a:t>Modelo de machine learning</a:t>
+            </a:r>
+          </a:p>
+        </p:txBody>
+      </p:sp>
+      <p:sp>
+        <p:nvSpPr>
+          <p:cNvPr id="30" name="TextBox 29"/>
+          <p:cNvSpPr txBox="1"/>
+          <p:nvPr/>
+        </p:nvSpPr>
+        <p:spPr>
+          <a:xfrm>
+            <a:off x="6885432" y="3785615"/>
+            <a:ext cx="4572000" cy="320040"/>
+          </a:xfrm>
+          <a:prstGeom prst="rect">
+            <a:avLst/>
+          </a:prstGeom>
+          <a:noFill/>
+        </p:spPr>
+        <p:txBody>
+          <a:bodyPr wrap="square" anchor="t">
+            <a:spAutoFit/>
+          </a:bodyPr>
+          <a:lstStyle/>
+          <a:p>
+            <a:pPr algn="l">
+              <a:spcAft>
+                <a:spcPts val="600"/>
+              </a:spcAft>
+            </a:pPr>
+            <a:r>
+              <a:rPr sz="1050" b="0" i="1">
+                <a:solidFill>
+                  <a:srgbClr val="8A9AA8"/>
+                </a:solidFill>
+                <a:latin typeface="Calibri"/>
+              </a:rPr>
+              <a:t>Mejora opcional si el tiempo alcanza</a:t>
+            </a:r>
+          </a:p>
+        </p:txBody>
+      </p:sp>
+      <p:sp>
+        <p:nvSpPr>
+          <p:cNvPr id="31" name="Rectangle 30"/>
+          <p:cNvSpPr/>
+          <p:nvPr/>
+        </p:nvSpPr>
+        <p:spPr>
+          <a:xfrm>
+            <a:off x="6583680" y="4361688"/>
+            <a:ext cx="118872" cy="118872"/>
+          </a:xfrm>
+          <a:prstGeom prst="rect">
+            <a:avLst/>
+          </a:prstGeom>
+          <a:solidFill>
+            <a:srgbClr val="8A9AA8"/>
+          </a:solidFill>
+          <a:ln>
+            <a:noFill/>
+          </a:ln>
+          <a:effectLst/>
+        </p:spPr>
+        <p:style>
+          <a:lnRef idx="1">
+            <a:schemeClr val="accent1"/>
+          </a:lnRef>
+          <a:fillRef idx="3">
+            <a:schemeClr val="accent1"/>
+          </a:fillRef>
+          <a:effectRef idx="2">
+            <a:schemeClr val="accent1"/>
+          </a:effectRef>
+          <a:fontRef idx="minor">
+            <a:schemeClr val="lt1"/>
+          </a:fontRef>
+        </p:style>
+        <p:txBody>
+          <a:bodyPr rtlCol="0" anchor="ctr"/>
+          <a:lstStyle/>
+          <a:p>
+            <a:pPr algn="ctr"/>
+          </a:p>
+        </p:txBody>
+      </p:sp>
+      <p:sp>
+        <p:nvSpPr>
+          <p:cNvPr id="32" name="TextBox 31"/>
+          <p:cNvSpPr txBox="1"/>
+          <p:nvPr/>
+        </p:nvSpPr>
+        <p:spPr>
+          <a:xfrm>
+            <a:off x="6885432" y="4242816"/>
+            <a:ext cx="4572000" cy="365760"/>
+          </a:xfrm>
+          <a:prstGeom prst="rect">
+            <a:avLst/>
+          </a:prstGeom>
+          <a:noFill/>
+        </p:spPr>
+        <p:txBody>
+          <a:bodyPr wrap="square" anchor="t">
+            <a:spAutoFit/>
+          </a:bodyPr>
+          <a:lstStyle/>
+          <a:p>
+            <a:pPr algn="l">
+              <a:spcAft>
+                <a:spcPts val="600"/>
+              </a:spcAft>
+            </a:pPr>
+            <a:r>
+              <a:rPr sz="1350" b="0" i="0">
+                <a:solidFill>
+                  <a:srgbClr val="22303C"/>
+                </a:solidFill>
+                <a:latin typeface="Calibri"/>
+              </a:rPr>
+              <a:t>Veterinario preferencial del tutor</a:t>
+            </a:r>
+          </a:p>
+        </p:txBody>
+      </p:sp>
+      <p:sp>
+        <p:nvSpPr>
+          <p:cNvPr id="33" name="TextBox 32"/>
+          <p:cNvSpPr txBox="1"/>
+          <p:nvPr/>
+        </p:nvSpPr>
+        <p:spPr>
+          <a:xfrm>
+            <a:off x="6885432" y="4535424"/>
+            <a:ext cx="4572000" cy="320040"/>
+          </a:xfrm>
+          <a:prstGeom prst="rect">
+            <a:avLst/>
+          </a:prstGeom>
+          <a:noFill/>
+        </p:spPr>
+        <p:txBody>
+          <a:bodyPr wrap="square" anchor="t">
+            <a:spAutoFit/>
+          </a:bodyPr>
+          <a:lstStyle/>
+          <a:p>
+            <a:pPr algn="l">
+              <a:spcAft>
+                <a:spcPts val="600"/>
+              </a:spcAft>
+            </a:pPr>
+            <a:r>
+              <a:rPr sz="1050" b="0" i="1">
+                <a:solidFill>
+                  <a:srgbClr val="8A9AA8"/>
+                </a:solidFill>
+                <a:latin typeface="Calibri"/>
+              </a:rPr>
+              <a:t>Mejora deseable</a:t>
+            </a:r>
+          </a:p>
+        </p:txBody>
+      </p:sp>
+      <p:sp>
+        <p:nvSpPr>
+          <p:cNvPr id="34" name="Rectangle 33"/>
+          <p:cNvSpPr/>
+          <p:nvPr/>
+        </p:nvSpPr>
+        <p:spPr>
+          <a:xfrm>
+            <a:off x="6583680" y="5111496"/>
+            <a:ext cx="118872" cy="118872"/>
+          </a:xfrm>
+          <a:prstGeom prst="rect">
+            <a:avLst/>
+          </a:prstGeom>
+          <a:solidFill>
+            <a:srgbClr val="8A9AA8"/>
+          </a:solidFill>
+          <a:ln>
+            <a:noFill/>
+          </a:ln>
+          <a:effectLst/>
+        </p:spPr>
+        <p:style>
+          <a:lnRef idx="1">
+            <a:schemeClr val="accent1"/>
+          </a:lnRef>
+          <a:fillRef idx="3">
+            <a:schemeClr val="accent1"/>
+          </a:fillRef>
+          <a:effectRef idx="2">
+            <a:schemeClr val="accent1"/>
+          </a:effectRef>
+          <a:fontRef idx="minor">
+            <a:schemeClr val="lt1"/>
+          </a:fontRef>
+        </p:style>
+        <p:txBody>
+          <a:bodyPr rtlCol="0" anchor="ctr"/>
+          <a:lstStyle/>
+          <a:p>
+            <a:pPr algn="ctr"/>
+          </a:p>
+        </p:txBody>
+      </p:sp>
+      <p:sp>
+        <p:nvSpPr>
+          <p:cNvPr id="35" name="TextBox 34"/>
+          <p:cNvSpPr txBox="1"/>
+          <p:nvPr/>
+        </p:nvSpPr>
+        <p:spPr>
+          <a:xfrm>
+            <a:off x="6885432" y="4992624"/>
+            <a:ext cx="4572000" cy="365760"/>
+          </a:xfrm>
+          <a:prstGeom prst="rect">
+            <a:avLst/>
+          </a:prstGeom>
+          <a:noFill/>
+        </p:spPr>
+        <p:txBody>
+          <a:bodyPr wrap="square" anchor="t">
+            <a:spAutoFit/>
+          </a:bodyPr>
+          <a:lstStyle/>
+          <a:p>
+            <a:pPr algn="l">
+              <a:spcAft>
+                <a:spcPts val="600"/>
+              </a:spcAft>
+            </a:pPr>
+            <a:r>
+              <a:rPr sz="1350" b="0" i="0">
+                <a:solidFill>
+                  <a:srgbClr val="22303C"/>
+                </a:solidFill>
+                <a:latin typeface="Calibri"/>
+              </a:rPr>
+              <a:t>Módulo de exámenes y laboratorios</a:t>
+            </a:r>
+          </a:p>
+        </p:txBody>
+      </p:sp>
+      <p:sp>
+        <p:nvSpPr>
+          <p:cNvPr id="36" name="TextBox 35"/>
+          <p:cNvSpPr txBox="1"/>
+          <p:nvPr/>
+        </p:nvSpPr>
+        <p:spPr>
+          <a:xfrm>
+            <a:off x="6885432" y="5285232"/>
+            <a:ext cx="4572000" cy="320040"/>
+          </a:xfrm>
+          <a:prstGeom prst="rect">
+            <a:avLst/>
+          </a:prstGeom>
+          <a:noFill/>
+        </p:spPr>
+        <p:txBody>
+          <a:bodyPr wrap="square" anchor="t">
+            <a:spAutoFit/>
+          </a:bodyPr>
+          <a:lstStyle/>
+          <a:p>
+            <a:pPr algn="l">
+              <a:spcAft>
+                <a:spcPts val="600"/>
+              </a:spcAft>
+            </a:pPr>
+            <a:r>
+              <a:rPr sz="1050" b="0" i="1">
+                <a:solidFill>
+                  <a:srgbClr val="8A9AA8"/>
+                </a:solidFill>
+                <a:latin typeface="Calibri"/>
+              </a:rPr>
+              <a:t>Mejora deseable</a:t>
+            </a:r>
+          </a:p>
+        </p:txBody>
+      </p:sp>
+      <p:sp>
+        <p:nvSpPr>
+          <p:cNvPr id="37" name="Rectangle 36"/>
+          <p:cNvSpPr/>
+          <p:nvPr/>
+        </p:nvSpPr>
+        <p:spPr>
+          <a:xfrm>
+            <a:off x="548640" y="6035040"/>
+            <a:ext cx="11100816" cy="566928"/>
+          </a:xfrm>
+          <a:prstGeom prst="rect">
+            <a:avLst/>
+          </a:prstGeom>
+          <a:solidFill>
+            <a:srgbClr val="1F3A5F"/>
+          </a:solidFill>
+          <a:ln>
+            <a:noFill/>
+          </a:ln>
+          <a:effectLst/>
+        </p:spPr>
+        <p:style>
+          <a:lnRef idx="1">
+            <a:schemeClr val="accent1"/>
+          </a:lnRef>
+          <a:fillRef idx="3">
+            <a:schemeClr val="accent1"/>
+          </a:fillRef>
+          <a:effectRef idx="2">
+            <a:schemeClr val="accent1"/>
+          </a:effectRef>
+          <a:fontRef idx="minor">
+            <a:schemeClr val="lt1"/>
+          </a:fontRef>
+        </p:style>
+        <p:txBody>
+          <a:bodyPr rtlCol="0" anchor="ctr"/>
+          <a:lstStyle/>
+          <a:p>
+            <a:pPr algn="ctr"/>
+          </a:p>
+        </p:txBody>
+      </p:sp>
+      <p:sp>
+        <p:nvSpPr>
+          <p:cNvPr id="38" name="TextBox 37"/>
+          <p:cNvSpPr txBox="1"/>
+          <p:nvPr/>
+        </p:nvSpPr>
+        <p:spPr>
+          <a:xfrm>
+            <a:off x="914400" y="6144768"/>
+            <a:ext cx="10424160" cy="384048"/>
+          </a:xfrm>
+          <a:prstGeom prst="rect">
+            <a:avLst/>
+          </a:prstGeom>
+          <a:noFill/>
+        </p:spPr>
+        <p:txBody>
+          <a:bodyPr wrap="square" anchor="t">
+            <a:spAutoFit/>
+          </a:bodyPr>
+          <a:lstStyle/>
+          <a:p>
+            <a:pPr algn="l">
+              <a:spcAft>
+                <a:spcPts val="600"/>
+              </a:spcAft>
+            </a:pPr>
+            <a:r>
+              <a:rPr sz="1400" b="1" i="0">
+                <a:solidFill>
+                  <a:srgbClr val="FFFFFF"/>
+                </a:solidFill>
+                <a:latin typeface="Calibri"/>
+              </a:rPr>
+              <a:t>Preferimos comprometer poco y cumplirlo, que prometer mucho y quedar debiendo.</a:t>
             </a:r>
           </a:p>
         </p:txBody>
@@ -23064,4 +26329,324 @@
   </a:objectDefaults>
   <a:extraClrSchemeLst/>
 </a:theme>
+</file>
+
+<file path=ppt/theme/theme2.xml><?xml version="1.0" encoding="utf-8"?>
+<a:theme xmlns:a="http://schemas.openxmlformats.org/drawingml/2006/main" name="Office Theme">
+  <a:themeElements>
+    <a:clrScheme name="Office">
+      <a:dk1>
+        <a:sysClr val="windowText" lastClr="000000"/>
+      </a:dk1>
+      <a:lt1>
+        <a:sysClr val="window" lastClr="FFFFFF"/>
+      </a:lt1>
+      <a:dk2>
+        <a:srgbClr val="1F497D"/>
+      </a:dk2>
+      <a:lt2>
+        <a:srgbClr val="EEECE1"/>
+      </a:lt2>
+      <a:accent1>
+        <a:srgbClr val="4F81BD"/>
+      </a:accent1>
+      <a:accent2>
+        <a:srgbClr val="C0504D"/>
+      </a:accent2>
+      <a:accent3>
+        <a:srgbClr val="9BBB59"/>
+      </a:accent3>
+      <a:accent4>
+        <a:srgbClr val="8064A2"/>
+      </a:accent4>
+      <a:accent5>
+        <a:srgbClr val="4BACC6"/>
+      </a:accent5>
+      <a:accent6>
+        <a:srgbClr val="F79646"/>
+      </a:accent6>
+      <a:hlink>
+        <a:srgbClr val="0000FF"/>
+      </a:hlink>
+      <a:folHlink>
+        <a:srgbClr val="800080"/>
+      </a:folHlink>
+    </a:clrScheme>
+    <a:fontScheme name="Office">
+      <a:majorFont>
+        <a:latin typeface="Calibri"/>
+        <a:ea typeface=""/>
+        <a:cs typeface=""/>
+        <a:font script="Jpan" typeface="ＭＳ Ｐゴシック"/>
+        <a:font script="Hang" typeface="맑은 고딕"/>
+        <a:font script="Hans" typeface="宋体"/>
+        <a:font script="Hant" typeface="新細明體"/>
+        <a:font script="Arab" typeface="Times New Roman"/>
+        <a:font script="Hebr" typeface="Times New Roman"/>
+        <a:font script="Thai" typeface="Angsana New"/>
+        <a:font script="Ethi" typeface="Nyala"/>
+        <a:font script="Beng" typeface="Vrinda"/>
+        <a:font script="Gujr" typeface="Shruti"/>
+        <a:font script="Khmr" typeface="MoolBoran"/>
+        <a:font script="Knda" typeface="Tunga"/>
+        <a:font script="Guru" typeface="Raavi"/>
+        <a:font script="Cans" typeface="Euphemia"/>
+        <a:font script="Cher" typeface="Plantagenet Cherokee"/>
+        <a:font script="Yiii" typeface="Microsoft Yi Baiti"/>
+        <a:font script="Tibt" typeface="Microsoft Himalaya"/>
+        <a:font script="Thaa" typeface="MV Boli"/>
+        <a:font script="Deva" typeface="Mangal"/>
+        <a:font script="Telu" typeface="Gautami"/>
+        <a:font script="Taml" typeface="Latha"/>
+        <a:font script="Syrc" typeface="Estrangelo Edessa"/>
+        <a:font script="Orya" typeface="Kalinga"/>
+        <a:font script="Mlym" typeface="Kartika"/>
+        <a:font script="Laoo" typeface="DokChampa"/>
+        <a:font script="Sinh" typeface="Iskoola Pota"/>
+        <a:font script="Mong" typeface="Mongolian Baiti"/>
+        <a:font script="Viet" typeface="Times New Roman"/>
+        <a:font script="Uigh" typeface="Microsoft Uighur"/>
+        <a:font script="Geor" typeface="Sylfaen"/>
+      </a:majorFont>
+      <a:minorFont>
+        <a:latin typeface="Calibri"/>
+        <a:ea typeface=""/>
+        <a:cs typeface=""/>
+        <a:font script="Jpan" typeface="ＭＳ Ｐゴシック"/>
+        <a:font script="Hang" typeface="맑은 고딕"/>
+        <a:font script="Hans" typeface="宋体"/>
+        <a:font script="Hant" typeface="新細明體"/>
+        <a:font script="Arab" typeface="Arial"/>
+        <a:font script="Hebr" typeface="Arial"/>
+        <a:font script="Thai" typeface="Cordia New"/>
+        <a:font script="Ethi" typeface="Nyala"/>
+        <a:font script="Beng" typeface="Vrinda"/>
+        <a:font script="Gujr" typeface="Shruti"/>
+        <a:font script="Khmr" typeface="DaunPenh"/>
+        <a:font script="Knda" typeface="Tunga"/>
+        <a:font script="Guru" typeface="Raavi"/>
+        <a:font script="Cans" typeface="Euphemia"/>
+        <a:font script="Cher" typeface="Plantagenet Cherokee"/>
+        <a:font script="Yiii" typeface="Microsoft Yi Baiti"/>
+        <a:font script="Tibt" typeface="Microsoft Himalaya"/>
+        <a:font script="Thaa" typeface="MV Boli"/>
+        <a:font script="Deva" typeface="Mangal"/>
+        <a:font script="Telu" typeface="Gautami"/>
+        <a:font script="Taml" typeface="Latha"/>
+        <a:font script="Syrc" typeface="Estrangelo Edessa"/>
+        <a:font script="Orya" typeface="Kalinga"/>
+        <a:font script="Mlym" typeface="Kartika"/>
+        <a:font script="Laoo" typeface="DokChampa"/>
+        <a:font script="Sinh" typeface="Iskoola Pota"/>
+        <a:font script="Mong" typeface="Mongolian Baiti"/>
+        <a:font script="Viet" typeface="Arial"/>
+        <a:font script="Uigh" typeface="Microsoft Uighur"/>
+        <a:font script="Geor" typeface="Sylfaen"/>
+      </a:minorFont>
+    </a:fontScheme>
+    <a:fmtScheme name="Office">
+      <a:fillStyleLst>
+        <a:solidFill>
+          <a:schemeClr val="phClr"/>
+        </a:solidFill>
+        <a:gradFill rotWithShape="1">
+          <a:gsLst>
+            <a:gs pos="0">
+              <a:schemeClr val="phClr">
+                <a:tint val="50000"/>
+                <a:satMod val="300000"/>
+              </a:schemeClr>
+            </a:gs>
+            <a:gs pos="35000">
+              <a:schemeClr val="phClr">
+                <a:tint val="37000"/>
+                <a:satMod val="300000"/>
+              </a:schemeClr>
+            </a:gs>
+            <a:gs pos="100000">
+              <a:schemeClr val="phClr">
+                <a:tint val="15000"/>
+                <a:satMod val="350000"/>
+              </a:schemeClr>
+            </a:gs>
+          </a:gsLst>
+          <a:lin ang="16200000" scaled="1"/>
+        </a:gradFill>
+        <a:gradFill rotWithShape="1">
+          <a:gsLst>
+            <a:gs pos="0">
+              <a:schemeClr val="phClr">
+                <a:tint val="100000"/>
+                <a:shade val="100000"/>
+                <a:satMod val="130000"/>
+              </a:schemeClr>
+            </a:gs>
+            <a:gs pos="100000">
+              <a:schemeClr val="phClr">
+                <a:tint val="50000"/>
+                <a:shade val="100000"/>
+                <a:satMod val="350000"/>
+              </a:schemeClr>
+            </a:gs>
+          </a:gsLst>
+          <a:lin ang="16200000" scaled="0"/>
+        </a:gradFill>
+      </a:fillStyleLst>
+      <a:lnStyleLst>
+        <a:ln w="9525" cap="flat" cmpd="sng" algn="ctr">
+          <a:solidFill>
+            <a:schemeClr val="phClr">
+              <a:shade val="95000"/>
+              <a:satMod val="105000"/>
+            </a:schemeClr>
+          </a:solidFill>
+          <a:prstDash val="solid"/>
+        </a:ln>
+        <a:ln w="25400" cap="flat" cmpd="sng" algn="ctr">
+          <a:solidFill>
+            <a:schemeClr val="phClr"/>
+          </a:solidFill>
+          <a:prstDash val="solid"/>
+        </a:ln>
+        <a:ln w="38100" cap="flat" cmpd="sng" algn="ctr">
+          <a:solidFill>
+            <a:schemeClr val="phClr"/>
+          </a:solidFill>
+          <a:prstDash val="solid"/>
+        </a:ln>
+      </a:lnStyleLst>
+      <a:effectStyleLst>
+        <a:effectStyle>
+          <a:effectLst>
+            <a:outerShdw blurRad="40000" dist="20000" dir="5400000" rotWithShape="0">
+              <a:srgbClr val="000000">
+                <a:alpha val="38000"/>
+              </a:srgbClr>
+            </a:outerShdw>
+          </a:effectLst>
+        </a:effectStyle>
+        <a:effectStyle>
+          <a:effectLst>
+            <a:outerShdw blurRad="40000" dist="23000" dir="5400000" rotWithShape="0">
+              <a:srgbClr val="000000">
+                <a:alpha val="35000"/>
+              </a:srgbClr>
+            </a:outerShdw>
+          </a:effectLst>
+        </a:effectStyle>
+        <a:effectStyle>
+          <a:effectLst>
+            <a:outerShdw blurRad="40000" dist="23000" dir="5400000" rotWithShape="0">
+              <a:srgbClr val="000000">
+                <a:alpha val="35000"/>
+              </a:srgbClr>
+            </a:outerShdw>
+          </a:effectLst>
+          <a:scene3d>
+            <a:camera prst="orthographicFront">
+              <a:rot lat="0" lon="0" rev="0"/>
+            </a:camera>
+            <a:lightRig rig="threePt" dir="t">
+              <a:rot lat="0" lon="0" rev="1200000"/>
+            </a:lightRig>
+          </a:scene3d>
+          <a:sp3d>
+            <a:bevelT w="63500" h="25400"/>
+          </a:sp3d>
+        </a:effectStyle>
+      </a:effectStyleLst>
+      <a:bgFillStyleLst>
+        <a:solidFill>
+          <a:schemeClr val="phClr"/>
+        </a:solidFill>
+        <a:gradFill rotWithShape="1">
+          <a:gsLst>
+            <a:gs pos="0">
+              <a:schemeClr val="phClr">
+                <a:tint val="40000"/>
+                <a:satMod val="350000"/>
+              </a:schemeClr>
+            </a:gs>
+            <a:gs pos="40000">
+              <a:schemeClr val="phClr">
+                <a:tint val="45000"/>
+                <a:shade val="99000"/>
+                <a:satMod val="350000"/>
+              </a:schemeClr>
+            </a:gs>
+            <a:gs pos="100000">
+              <a:schemeClr val="phClr">
+                <a:shade val="20000"/>
+                <a:satMod val="255000"/>
+              </a:schemeClr>
+            </a:gs>
+          </a:gsLst>
+          <a:path path="circle">
+            <a:fillToRect l="50000" t="-80000" r="50000" b="180000"/>
+          </a:path>
+        </a:gradFill>
+        <a:gradFill rotWithShape="1">
+          <a:gsLst>
+            <a:gs pos="0">
+              <a:schemeClr val="phClr">
+                <a:tint val="80000"/>
+                <a:satMod val="300000"/>
+              </a:schemeClr>
+            </a:gs>
+            <a:gs pos="100000">
+              <a:schemeClr val="phClr">
+                <a:shade val="30000"/>
+                <a:satMod val="200000"/>
+              </a:schemeClr>
+            </a:gs>
+          </a:gsLst>
+          <a:path path="circle">
+            <a:fillToRect l="50000" t="50000" r="50000" b="50000"/>
+          </a:path>
+        </a:gradFill>
+      </a:bgFillStyleLst>
+    </a:fmtScheme>
+  </a:themeElements>
+  <a:objectDefaults>
+    <a:spDef>
+      <a:spPr/>
+      <a:bodyPr/>
+      <a:lstStyle/>
+      <a:style>
+        <a:lnRef idx="1">
+          <a:schemeClr val="accent1"/>
+        </a:lnRef>
+        <a:fillRef idx="3">
+          <a:schemeClr val="accent1"/>
+        </a:fillRef>
+        <a:effectRef idx="2">
+          <a:schemeClr val="accent1"/>
+        </a:effectRef>
+        <a:fontRef idx="minor">
+          <a:schemeClr val="lt1"/>
+        </a:fontRef>
+      </a:style>
+    </a:spDef>
+    <a:lnDef>
+      <a:spPr/>
+      <a:bodyPr/>
+      <a:lstStyle/>
+      <a:style>
+        <a:lnRef idx="2">
+          <a:schemeClr val="accent1"/>
+        </a:lnRef>
+        <a:fillRef idx="0">
+          <a:schemeClr val="accent1"/>
+        </a:fillRef>
+        <a:effectRef idx="1">
+          <a:schemeClr val="accent1"/>
+        </a:effectRef>
+        <a:fontRef idx="minor">
+          <a:schemeClr val="tx1"/>
+        </a:fontRef>
+      </a:style>
+    </a:lnDef>
+  </a:objectDefaults>
+  <a:extraClrSchemeLst/>
+</a:theme>
 </file>
</xml_diff>

<commit_message>
Agrega el guion de presentacion y acorta las notas de la PPT
- Nuevo Guion_Presentacion_PreVet.docx: una tabla con quien habla, que
  lamina, cuanto dura y las frases exactas que decir, mas una seccion de
  preguntas probables con su respuesta.
- Las notas dentro de la PPT ahora dicen lo mismo, en frases cortas.

Co-Authored-By: Claude Opus 5 <noreply@anthropic.com>
</commit_message>
<xml_diff>
--- a/Fase 1/Evidencias Grupales/Presentacion_PreVet_Fase1.pptx
+++ b/Fase 1/Evidencias Grupales/Presentacion_PreVet_Fase1.pptx
@@ -519,13 +519,23 @@
           <a:lstStyle/>
           <a:p>
             <a:r>
-              <a:t>UCIELL — Apertura (30 s)</a:t>
+              <a:t>UCIELL · Portada · 20 s</a:t>
             </a:r>
           </a:p>
           <a:p/>
           <a:p>
             <a:r>
-              <a:t>Buenos días. Somos Katalina Mora y Uciell Madrid. Nuestro proyecto se llama PreVet y resuelve un problema que las clínicas veterinarias pequeñas tienen todos los días y no pueden ni siquiera medir.</a:t>
+              <a:t>Buenos días. Somos Katalina Mora y Uciell Madrid.</a:t>
+            </a:r>
+          </a:p>
+          <a:p>
+            <a:r>
+              <a:t>Nuestro proyecto se llama PreVet.</a:t>
+            </a:r>
+          </a:p>
+          <a:p>
+            <a:r>
+              <a:t>Resuelve un problema que las clínicas veterinarias chicas tienen todos los días y no pueden medir.</a:t>
             </a:r>
           </a:p>
         </p:txBody>
@@ -595,13 +605,23 @@
           <a:lstStyle/>
           <a:p>
             <a:r>
-              <a:t>UCIELL — Mock-up de la app (1 min)</a:t>
+              <a:t>UCIELL · Mock-up de la app · 45 s</a:t>
             </a:r>
           </a:p>
           <a:p/>
           <a:p>
             <a:r>
-              <a:t>Así se vería la app del tutor: elegir tipo de atención, elegir profesional, y gestionar sus horas. Lo importante no es que sea bonita: es el canal que captura los datos que hoy no existen — quién reserva, cuándo, con cuánta anticipación, si confirma o cancela. Sin esos datos no hay predicción posible.</a:t>
+              <a:t>Así se vería la app del tutor: elegir atención, elegir profesional y ver sus horas.</a:t>
+            </a:r>
+          </a:p>
+          <a:p>
+            <a:r>
+              <a:t>Pero lo importante no es la app.</a:t>
+            </a:r>
+          </a:p>
+          <a:p>
+            <a:r>
+              <a:t>→ Es el canal que captura los datos que hoy no existen. Sin datos no hay predicción.</a:t>
             </a:r>
           </a:p>
         </p:txBody>
@@ -671,13 +691,28 @@
           <a:lstStyle/>
           <a:p>
             <a:r>
-              <a:t>KATALINA — Mock-up del tablero (1,5 min)</a:t>
+              <a:t>KATALINA · Mock-up del tablero · 60 s</a:t>
             </a:r>
           </a:p>
           <a:p/>
           <a:p>
             <a:r>
-              <a:t>Esto es lo que ve la administradora de la clínica cada mañana. Arriba los indicadores: cuántas horas se agendaron, la tasa de inasistencia y cuánto dinero representa. Abajo a la izquierda el patrón por día. Y a la derecha lo importante: las horas en riesgo de los próximos días, con la acción recomendada para cada una. Los números son de ejemplo; los reales salen de la entrevista con la clínica.</a:t>
+              <a:t>Esto es lo que ve la administradora cada mañana.</a:t>
+            </a:r>
+          </a:p>
+          <a:p>
+            <a:r>
+              <a:t>Arriba: cuántas horas se agendaron, cuántas se pierden y cuánto dinero representa.</a:t>
+            </a:r>
+          </a:p>
+          <a:p>
+            <a:r>
+              <a:t>A la derecha lo clave: las horas en riesgo, y qué hacer con cada una.</a:t>
+            </a:r>
+          </a:p>
+          <a:p>
+            <a:r>
+              <a:t>Los números son de ejemplo. Los reales salen de la entrevista con la clínica.</a:t>
             </a:r>
           </a:p>
         </p:txBody>
@@ -747,13 +782,18 @@
           <a:lstStyle/>
           <a:p>
             <a:r>
-              <a:t>KATALINA — Arquitectura (1 min)</a:t>
+              <a:t>KATALINA · Arquitectura · 40 s</a:t>
             </a:r>
           </a:p>
           <a:p/>
           <a:p>
             <a:r>
-              <a:t>Las dos primeras filas marcan la diferencia: el sistema base es preexistente, la extensión es nuestra. El resto son herramientas gratuitas o de licencia estudiante, así que el proyecto no requiere inversión. El tablero va en Power BI conectado a la misma base.</a:t>
+              <a:t>Las dos primeras filas marcan la diferencia: el sistema base ya existía, la extensión es nuestra.</a:t>
+            </a:r>
+          </a:p>
+          <a:p>
+            <a:r>
+              <a:t>→ El resto son herramientas gratuitas. El proyecto no requiere inversión.</a:t>
             </a:r>
           </a:p>
         </p:txBody>
@@ -823,13 +863,28 @@
           <a:lstStyle/>
           <a:p>
             <a:r>
-              <a:t>UCIELL — Metodología (1 min)</a:t>
+              <a:t>UCIELL · Metodología · 50 s</a:t>
             </a:r>
           </a:p>
           <a:p/>
           <a:p>
             <a:r>
-              <a:t>Usamos dos marcos que no compiten. CRISP-DM ordena el trabajo analítico, que es el estándar en proyectos de datos. Y un marco ágil ordena la gestión, en incrementos de dos semanas con un entregable verificable cada uno. Más gestión de riesgos y plan de pruebas de forma transversal. Si preguntan por qué dos: una es para el análisis, la otra para la gestión.</a:t>
+              <a:t>Usamos dos marcos, y no compiten entre sí.</a:t>
+            </a:r>
+          </a:p>
+          <a:p>
+            <a:r>
+              <a:t>CRISP-DM ordena el trabajo con los datos. Es el estándar en proyectos de análisis.</a:t>
+            </a:r>
+          </a:p>
+          <a:p>
+            <a:r>
+              <a:t>Y un marco ágil ordena la gestión, en tramos de dos semanas con un entregable cada uno.</a:t>
+            </a:r>
+          </a:p>
+          <a:p>
+            <a:r>
+              <a:t>→ Si preguntan: una es para el análisis, la otra para la gestión.</a:t>
             </a:r>
           </a:p>
         </p:txBody>
@@ -899,13 +954,23 @@
           <a:lstStyle/>
           <a:p>
             <a:r>
-              <a:t>UCIELL — Competencias (45 s)</a:t>
+              <a:t>UCIELL · Competencias · 40 s</a:t>
             </a:r>
           </a:p>
           <a:p/>
           <a:p>
             <a:r>
-              <a:t>El proyecto pone en práctica tres competencias del perfil de egreso, y en la última columna está el indicador de calidad que cubre cada una. Las seis certificaciones de módulo que tenemos respaldan justamente estas áreas.</a:t>
+              <a:t>El proyecto aplica tres competencias del perfil de egreso.</a:t>
+            </a:r>
+          </a:p>
+          <a:p>
+            <a:r>
+              <a:t>En la última columna está el indicador de calidad que cubre cada una.</a:t>
+            </a:r>
+          </a:p>
+          <a:p>
+            <a:r>
+              <a:t>→ Las seis certificaciones de módulo que tenemos respaldan justamente estas áreas.</a:t>
             </a:r>
           </a:p>
         </p:txBody>
@@ -975,13 +1040,23 @@
           <a:lstStyle/>
           <a:p>
             <a:r>
-              <a:t>AMBAS — El equipo (45 s)</a:t>
+              <a:t>AMBAS · El equipo · 40 s</a:t>
             </a:r>
           </a:p>
           <a:p/>
           <a:p>
             <a:r>
-              <a:t>Katalina: datos, modelo de riesgo, tablero y gestión del proyecto. Uciell: análisis funcional, preparación de datos, prototipo y calidad. Cada una explica su propia parte en esta lámina.</a:t>
+              <a:t>KATALINA: Yo llevo los datos, el modelo de riesgo, el tablero y la gestión del proyecto.</a:t>
+            </a:r>
+          </a:p>
+          <a:p>
+            <a:r>
+              <a:t>UCIELL: Yo llevo el análisis funcional, la preparación de datos, el prototipo y la calidad.</a:t>
+            </a:r>
+          </a:p>
+          <a:p>
+            <a:r>
+              <a:t>→ La definición, la validación con la clínica y el informe los hacemos juntas.</a:t>
             </a:r>
           </a:p>
         </p:txBody>
@@ -1051,13 +1126,18 @@
           <a:lstStyle/>
           <a:p>
             <a:r>
-              <a:t>KATALINA — Plan de trabajo (45 s)</a:t>
+              <a:t>KATALINA · Plan de trabajo · 35 s</a:t>
             </a:r>
           </a:p>
           <a:p/>
           <a:p>
             <a:r>
-              <a:t>Doce actividades en las 18 semanas, repartidas en las tres fases. Fíjense en que las actividades se superponen a propósito, para que ninguna de las dos quede esperando el trabajo de la otra.</a:t>
+              <a:t>Doce actividades repartidas en las 18 semanas.</a:t>
+            </a:r>
+          </a:p>
+          <a:p>
+            <a:r>
+              <a:t>→ Se superponen a propósito, para que ninguna de las dos quede esperando a la otra.</a:t>
             </a:r>
           </a:p>
         </p:txBody>
@@ -1127,13 +1207,23 @@
           <a:lstStyle/>
           <a:p>
             <a:r>
-              <a:t>KATALINA — Riesgos (1 min)</a:t>
+              <a:t>KATALINA · Riesgos · 45 s</a:t>
             </a:r>
           </a:p>
           <a:p/>
           <a:p>
             <a:r>
-              <a:t>El riesgo principal era no tener datos históricos, y lo resolvimos: el sistema base ya trae un generador de datos de demostración que vamos a extender para producir historial de inasistencias con las tasas reales que nos reporte la clínica. Y la frase de abajo es importante: el proyecto se completa aunque el machine learning no alcance a desarrollarse.</a:t>
+              <a:t>El riesgo principal era no tener datos históricos. Ya está resuelto.</a:t>
+            </a:r>
+          </a:p>
+          <a:p>
+            <a:r>
+              <a:t>El sistema base genera datos de demostración; lo extendemos con las tasas reales de la clínica.</a:t>
+            </a:r>
+          </a:p>
+          <a:p>
+            <a:r>
+              <a:t>→ Y esto importa: el proyecto se completa aunque el machine learning no alcance.</a:t>
             </a:r>
           </a:p>
         </p:txBody>
@@ -1203,13 +1293,23 @@
           <a:lstStyle/>
           <a:p>
             <a:r>
-              <a:t>UCIELL — Cierre (30 s)</a:t>
+              <a:t>UCIELL · Cierre · 25 s</a:t>
             </a:r>
           </a:p>
           <a:p/>
           <a:p>
             <a:r>
-              <a:t>Para cerrar: las clínicas veterinarias chicas pierden horas y ni siquiera pueden medir cuántas. PreVet estructura esos datos y anticipa qué hora se va a perder, antes de que ocurra. Muchas gracias. Quedamos atentas a sus preguntas.</a:t>
+              <a:t>Para cerrar: las clínicas chicas pierden horas y ni siquiera pueden medir cuántas.</a:t>
+            </a:r>
+          </a:p>
+          <a:p>
+            <a:r>
+              <a:t>PreVet anticipa qué hora se va a perder, antes de que ocurra.</a:t>
+            </a:r>
+          </a:p>
+          <a:p>
+            <a:r>
+              <a:t>Muchas gracias. Quedamos atentas a sus preguntas.</a:t>
             </a:r>
           </a:p>
         </p:txBody>
@@ -1279,13 +1379,28 @@
           <a:lstStyle/>
           <a:p>
             <a:r>
-              <a:t>UCIELL — El problema (1 min)</a:t>
+              <a:t>UCIELL · El problema · 50 s</a:t>
             </a:r>
           </a:p>
           <a:p/>
           <a:p>
             <a:r>
-              <a:t>Las clínicas chicas agendan por WhatsApp, teléfono e Instagram. Eso genera dos problemas. El primero: la gente no llega a su hora, y ese bloque se pierde. El segundo, y más grave: como no hay registro, la clínica no sabe cuántas horas pierde ni cuánto le cuesta. Frase para cerrar: un problema que no se mide, no se puede gestionar.</a:t>
+              <a:t>Las clínicas chicas agendan por WhatsApp, teléfono e Instagram.</a:t>
+            </a:r>
+          </a:p>
+          <a:p>
+            <a:r>
+              <a:t>Pasan dos cosas. La primera: la gente no llega a su hora y ese bloque se pierde.</a:t>
+            </a:r>
+          </a:p>
+          <a:p>
+            <a:r>
+              <a:t>La segunda, más grave: como no hay registro, la clínica no sabe cuántas horas pierde.</a:t>
+            </a:r>
+          </a:p>
+          <a:p>
+            <a:r>
+              <a:t>→ Un problema que no se mide, no se puede gestionar.</a:t>
             </a:r>
           </a:p>
         </p:txBody>
@@ -1355,13 +1470,23 @@
           <a:lstStyle/>
           <a:p>
             <a:r>
-              <a:t>UCIELL — Contexto (45 s)</a:t>
+              <a:t>UCIELL · Dónde y a quiénes · 40 s</a:t>
             </a:r>
           </a:p>
           <a:p/>
           <a:p>
             <a:r>
-              <a:t>Trabajamos con la Clínica Veterinaria Clan, en Lo Pinto, y con otras de Batuco. Son clínicas chicas, de equipo reducido, fuera del radio de las grandes cadenas. El sector es grande: 12,4 millones de mascotas con tutor en Chile, y las veterinarias crecieron 22% en la Región Metropolitana durante 2025.</a:t>
+              <a:t>Trabajamos con la Clínica Clan, de Lo Pinto, y con otras de Batuco.</a:t>
+            </a:r>
+          </a:p>
+          <a:p>
+            <a:r>
+              <a:t>Son clínicas chicas, de equipo reducido, lejos de las grandes cadenas.</a:t>
+            </a:r>
+          </a:p>
+          <a:p>
+            <a:r>
+              <a:t>El sector es grande: 12 millones de mascotas en Chile, y las veterinarias crecieron 22% en la Región Metropolitana.</a:t>
             </a:r>
           </a:p>
         </p:txBody>
@@ -1431,13 +1556,23 @@
           <a:lstStyle/>
           <a:p>
             <a:r>
-              <a:t>UCIELL — El mercado (1 min)</a:t>
+              <a:t>UCIELL · Lo que ya existe · 45 s</a:t>
             </a:r>
           </a:p>
           <a:p/>
           <a:p>
             <a:r>
-              <a:t>Revisamos lo que ya existe: Wirevet, GVET, VeteSoft y otras. El punto importante es la última columna: TODAS resuelven la inasistencia igual, mandando un recordatorio idéntico a todo el mundo. Ninguna distingue el riesgo de cada caso.</a:t>
+              <a:t>Revisamos la oferta que hay en Chile: Wirevet, GVET, VeteSoft y otras.</a:t>
+            </a:r>
+          </a:p>
+          <a:p>
+            <a:r>
+              <a:t>Miren la última columna: todas hacen exactamente lo mismo.</a:t>
+            </a:r>
+          </a:p>
+          <a:p>
+            <a:r>
+              <a:t>→ Mandan el mismo recordatorio a todos. Ninguna mira el riesgo de cada caso.</a:t>
             </a:r>
           </a:p>
         </p:txBody>
@@ -1507,13 +1642,23 @@
           <a:lstStyle/>
           <a:p>
             <a:r>
-              <a:t>UCIELL — La brecha (1 min)</a:t>
+              <a:t>UCIELL · La brecha · 45 s</a:t>
             </a:r>
           </a:p>
           <a:p/>
           <a:p>
             <a:r>
-              <a:t>Dos hallazgos. Primero: la tecnología existe, pero parte en 59.990 pesos mensuales y no llega a las clínicas chicas. Eso es una brecha de adopción, no de tecnología. Segundo, y es el que nos importa: nadie predice qué hora se va a perder. OJO: si preguntan, aclarar que no decimos que no existan apps veterinarias — sí existen.</a:t>
+              <a:t>Encontramos dos brechas.</a:t>
+            </a:r>
+          </a:p>
+          <a:p>
+            <a:r>
+              <a:t>La primera: esos softwares parten en 60 mil pesos al mes. No llegan a las clínicas chicas.</a:t>
+            </a:r>
+          </a:p>
+          <a:p>
+            <a:r>
+              <a:t>→ La segunda, y es la importante: nadie predice qué hora se va a perder.</a:t>
             </a:r>
           </a:p>
         </p:txBody>
@@ -1583,19 +1728,28 @@
           <a:lstStyle/>
           <a:p>
             <a:r>
-              <a:t>KATALINA — El punto de partida (1 min)</a:t>
+              <a:t>KATALINA · El punto de partida · 50 s</a:t>
             </a:r>
           </a:p>
           <a:p/>
           <a:p>
             <a:r>
-              <a:t>No partimos de cero: ya teníamos un sistema de gestión veterinaria funcionando. Al analizarlo encontramos el hueco: una cita solo puede estar pendiente, completada o cancelada. No existe 'no asistió'. Entonces, si el tutor no llega, esa cita queda pendiente para siempre y la clínica nunca sabe cuánto perdió. Ahí entra nuestro proyecto.</a:t>
-            </a:r>
-          </a:p>
-          <a:p/>
-          <a:p>
-            <a:r>
-              <a:t>SI PREGUNTAN POR LA AUTORÍA: el sistema base lo desarrollé antes de esta asignatura junto a una colaboradora externa; está declarado en la sección 2.9 del informe. El aporte del equipo es el módulo de riesgo de inasistencia.</a:t>
+              <a:t>No partimos de cero. Ya teníamos un sistema veterinario funcionando.</a:t>
+            </a:r>
+          </a:p>
+          <a:p>
+            <a:r>
+              <a:t>Al revisarlo encontramos el hueco: una cita solo puede estar pendiente, completada o cancelada.</a:t>
+            </a:r>
+          </a:p>
+          <a:p>
+            <a:r>
+              <a:t>→ No existe «no asistió». Si el tutor no llega, la cita queda pendiente para siempre.</a:t>
+            </a:r>
+          </a:p>
+          <a:p>
+            <a:r>
+              <a:t>Ahí entra PreVet.</a:t>
             </a:r>
           </a:p>
         </p:txBody>
@@ -1665,13 +1819,28 @@
           <a:lstStyle/>
           <a:p>
             <a:r>
-              <a:t>KATALINA — La innovación (1 min)</a:t>
+              <a:t>KATALINA · La innovación · 50 s</a:t>
             </a:r>
           </a:p>
           <a:p/>
           <a:p>
             <a:r>
-              <a:t>Acá está el corazón del proyecto. Hoy el mercado es reactivo: manda un recordatorio igual para todos. Nosotras calculamos el riesgo de cada hora antes de que llegue el día, usando el historial del tutor, la anticipación de la reserva, el día y el tipo de atención. Lo que hacemos es traer a las veterinarias los modelos de predicción de inasistencia que en salud humana ya están validados.</a:t>
+              <a:t>Hoy el mercado reacciona: manda un recordatorio igual para todos.</a:t>
+            </a:r>
+          </a:p>
+          <a:p>
+            <a:r>
+              <a:t>Nosotras calculamos el riesgo de cada hora antes de que llegue el día.</a:t>
+            </a:r>
+          </a:p>
+          <a:p>
+            <a:r>
+              <a:t>Usamos el historial del tutor, la anticipación de la reserva, el día y el tipo de atención.</a:t>
+            </a:r>
+          </a:p>
+          <a:p>
+            <a:r>
+              <a:t>→ Es traer a las veterinarias algo que en salud humana ya está validado.</a:t>
             </a:r>
           </a:p>
         </p:txBody>
@@ -1741,13 +1910,23 @@
           <a:lstStyle/>
           <a:p>
             <a:r>
-              <a:t>KATALINA — La solución (1 min)</a:t>
+              <a:t>KATALINA · La solución · 45 s</a:t>
             </a:r>
           </a:p>
           <a:p/>
           <a:p>
             <a:r>
-              <a:t>Cinco etapas, y el orden importa. Primero formalizamos el proceso, después estructuramos los datos, después medimos, recién ahí predecimos, y finalmente recomendamos qué hacer. La frase: primero lo hacemos medible, después lo hacemos predecible.</a:t>
+              <a:t>Cinco etapas, y el orden importa.</a:t>
+            </a:r>
+          </a:p>
+          <a:p>
+            <a:r>
+              <a:t>Formalizar, estructurar, medir, predecir y recomendar.</a:t>
+            </a:r>
+          </a:p>
+          <a:p>
+            <a:r>
+              <a:t>→ Primero lo hacemos medible. Después lo hacemos predecible.</a:t>
             </a:r>
           </a:p>
         </p:txBody>
@@ -1817,13 +1996,28 @@
           <a:lstStyle/>
           <a:p>
             <a:r>
-              <a:t>KATALINA — Alcance comprometido (1 min)</a:t>
+              <a:t>KATALINA · Alcance comprometido · 45 s</a:t>
             </a:r>
           </a:p>
           <a:p/>
           <a:p>
             <a:r>
-              <a:t>Esta lámina es para dejar cerrado el alcance, como pidió el profesor. A la izquierda lo que nos comprometemos a entregar. A la derecha lo que dejamos explícitamente fuera: la app móvil se entrega como prototipo, no construida, y el machine learning es una mejora opcional. El modelo base de riesgo va en SQL, así que el proyecto se completa igual aunque esa parte no alcance.</a:t>
+              <a:t>Acá dejamos cerrado el alcance, como pidió usted, profesor.</a:t>
+            </a:r>
+          </a:p>
+          <a:p>
+            <a:r>
+              <a:t>A la izquierda lo que entregamos. A la derecha lo que queda fuera.</a:t>
+            </a:r>
+          </a:p>
+          <a:p>
+            <a:r>
+              <a:t>La app va como prototipo, no construida. El machine learning es una mejora opcional.</a:t>
+            </a:r>
+          </a:p>
+          <a:p>
+            <a:r>
+              <a:t>→ Preferimos comprometer poco y cumplirlo.</a:t>
             </a:r>
           </a:p>
         </p:txBody>

</xml_diff>